<commit_message>
docs: update project presentation and add lock file for concurrency management
</commit_message>
<xml_diff>
--- a/docs/BiteKing POS Presentation.pptx
+++ b/docs/BiteKing POS Presentation.pptx
@@ -145,7 +145,7 @@
       </p:grpSpPr>
       <p:sp>
         <p:nvSpPr>
-          <p:cNvPr id="2" name="Header Placeholder 1"/>
+          <p:cNvPr id="1353723704" name="Header Placeholder 1"/>
           <p:cNvSpPr>
             <a:spLocks noGrp="1"/>
           </p:cNvSpPr>
@@ -179,7 +179,7 @@
       </p:sp>
       <p:sp>
         <p:nvSpPr>
-          <p:cNvPr id="3" name="Date Placeholder 2"/>
+          <p:cNvPr id="502430359" name="Date Placeholder 2"/>
           <p:cNvSpPr>
             <a:spLocks noGrp="1"/>
           </p:cNvSpPr>
@@ -213,7 +213,7 @@
       </p:sp>
       <p:sp>
         <p:nvSpPr>
-          <p:cNvPr id="3" name="Date Placeholder 2"/>
+          <p:cNvPr id="1242745494" name="Date Placeholder 2"/>
           <p:cNvSpPr>
             <a:spLocks noGrp="1"/>
           </p:cNvSpPr>
@@ -247,7 +247,7 @@
       </p:sp>
       <p:sp>
         <p:nvSpPr>
-          <p:cNvPr id="5" name="Notes Placeholder 4"/>
+          <p:cNvPr id="824127246" name="Notes Placeholder 4"/>
           <p:cNvSpPr>
             <a:spLocks noGrp="1"/>
           </p:cNvSpPr>
@@ -277,7 +277,7 @@
       </p:sp>
       <p:sp>
         <p:nvSpPr>
-          <p:cNvPr id="6" name="Footer Placeholder 5"/>
+          <p:cNvPr id="206546650" name="Footer Placeholder 5"/>
           <p:cNvSpPr>
             <a:spLocks noGrp="1"/>
           </p:cNvSpPr>
@@ -311,7 +311,7 @@
       </p:sp>
       <p:sp>
         <p:nvSpPr>
-          <p:cNvPr id="7" name="Slide Number Placeholder 6"/>
+          <p:cNvPr id="1399428926" name="Slide Number Placeholder 6"/>
           <p:cNvSpPr>
             <a:spLocks noGrp="1"/>
           </p:cNvSpPr>
@@ -346,6 +346,7 @@
     </p:spTree>
   </p:cSld>
   <p:clrMap bg1="lt1" tx1="dk1" bg2="lt2" tx2="dk2" accent1="accent1" accent2="accent2" accent3="accent3" accent4="accent4" accent5="accent5" accent6="accent6" hlink="hlink" folHlink="folHlink"/>
+  <p:hf dt="0" ftr="0" hdr="0" sldNum="1"/>
   <p:notesStyle>
     <a:lvl1pPr marL="0" algn="l" defTabSz="914400">
       <a:defRPr sz="1200">
@@ -460,7 +461,7 @@
       </p:grpSpPr>
       <p:sp>
         <p:nvSpPr>
-          <p:cNvPr id="2" name="Slide Image Placeholder 1"/>
+          <p:cNvPr id="999276709" name="Slide Image Placeholder 1"/>
           <p:cNvSpPr>
             <a:spLocks noChangeAspect="1" noGrp="1" noRot="1"/>
           </p:cNvSpPr>
@@ -472,7 +473,7 @@
       </p:sp>
       <p:sp>
         <p:nvSpPr>
-          <p:cNvPr id="3" name="Notes Placeholder 2"/>
+          <p:cNvPr id="2104855920" name="Notes Placeholder 2"/>
           <p:cNvSpPr>
             <a:spLocks noGrp="1"/>
           </p:cNvSpPr>
@@ -494,7 +495,7 @@
       </p:sp>
       <p:sp>
         <p:nvSpPr>
-          <p:cNvPr id="4" name="Slide Number Placeholder 3"/>
+          <p:cNvPr id="1313224530" name="Slide Number Placeholder 3"/>
           <p:cNvSpPr>
             <a:spLocks noGrp="1"/>
           </p:cNvSpPr>
@@ -545,7 +546,7 @@
       </p:grpSpPr>
       <p:sp>
         <p:nvSpPr>
-          <p:cNvPr id="2" name="Slide Image Placeholder 1"/>
+          <p:cNvPr id="1844159958" name="Slide Image Placeholder 1"/>
           <p:cNvSpPr>
             <a:spLocks noChangeAspect="1" noGrp="1" noRot="1"/>
           </p:cNvSpPr>
@@ -557,7 +558,7 @@
       </p:sp>
       <p:sp>
         <p:nvSpPr>
-          <p:cNvPr id="3" name="Notes Placeholder 2"/>
+          <p:cNvPr id="1502309298" name="Notes Placeholder 2"/>
           <p:cNvSpPr>
             <a:spLocks noGrp="1"/>
           </p:cNvSpPr>
@@ -579,7 +580,7 @@
       </p:sp>
       <p:sp>
         <p:nvSpPr>
-          <p:cNvPr id="4" name="Slide Number Placeholder 3"/>
+          <p:cNvPr id="803293797" name="Slide Number Placeholder 3"/>
           <p:cNvSpPr>
             <a:spLocks noGrp="1"/>
           </p:cNvSpPr>
@@ -630,7 +631,7 @@
       </p:grpSpPr>
       <p:sp>
         <p:nvSpPr>
-          <p:cNvPr id="2" name="Slide Image Placeholder 1"/>
+          <p:cNvPr id="1974769089" name="Slide Image Placeholder 1"/>
           <p:cNvSpPr>
             <a:spLocks noChangeAspect="1" noGrp="1" noRot="1"/>
           </p:cNvSpPr>
@@ -642,7 +643,7 @@
       </p:sp>
       <p:sp>
         <p:nvSpPr>
-          <p:cNvPr id="3" name="Notes Placeholder 2"/>
+          <p:cNvPr id="194072697" name="Notes Placeholder 2"/>
           <p:cNvSpPr>
             <a:spLocks noGrp="1"/>
           </p:cNvSpPr>
@@ -664,7 +665,7 @@
       </p:sp>
       <p:sp>
         <p:nvSpPr>
-          <p:cNvPr id="4" name="Slide Number Placeholder 3"/>
+          <p:cNvPr id="12253575" name="Slide Number Placeholder 3"/>
           <p:cNvSpPr>
             <a:spLocks noGrp="1"/>
           </p:cNvSpPr>
@@ -715,7 +716,7 @@
       </p:grpSpPr>
       <p:sp>
         <p:nvSpPr>
-          <p:cNvPr id="2" name="Slide Image Placeholder 1"/>
+          <p:cNvPr id="1935897967" name="Slide Image Placeholder 1"/>
           <p:cNvSpPr>
             <a:spLocks noChangeAspect="1" noGrp="1" noRot="1"/>
           </p:cNvSpPr>
@@ -727,7 +728,7 @@
       </p:sp>
       <p:sp>
         <p:nvSpPr>
-          <p:cNvPr id="3" name="Notes Placeholder 2"/>
+          <p:cNvPr id="361171757" name="Notes Placeholder 2"/>
           <p:cNvSpPr>
             <a:spLocks noGrp="1"/>
           </p:cNvSpPr>
@@ -749,7 +750,7 @@
       </p:sp>
       <p:sp>
         <p:nvSpPr>
-          <p:cNvPr id="4" name="Slide Number Placeholder 3"/>
+          <p:cNvPr id="1348290311" name="Slide Number Placeholder 3"/>
           <p:cNvSpPr>
             <a:spLocks noGrp="1"/>
           </p:cNvSpPr>
@@ -800,7 +801,7 @@
       </p:grpSpPr>
       <p:sp>
         <p:nvSpPr>
-          <p:cNvPr id="2" name="Slide Image Placeholder 1"/>
+          <p:cNvPr id="1167001097" name="Slide Image Placeholder 1"/>
           <p:cNvSpPr>
             <a:spLocks noChangeAspect="1" noGrp="1" noRot="1"/>
           </p:cNvSpPr>
@@ -812,7 +813,7 @@
       </p:sp>
       <p:sp>
         <p:nvSpPr>
-          <p:cNvPr id="3" name="Notes Placeholder 2"/>
+          <p:cNvPr id="214028075" name="Notes Placeholder 2"/>
           <p:cNvSpPr>
             <a:spLocks noGrp="1"/>
           </p:cNvSpPr>
@@ -834,7 +835,7 @@
       </p:sp>
       <p:sp>
         <p:nvSpPr>
-          <p:cNvPr id="4" name="Slide Number Placeholder 3"/>
+          <p:cNvPr id="1839410647" name="Slide Number Placeholder 3"/>
           <p:cNvSpPr>
             <a:spLocks noGrp="1"/>
           </p:cNvSpPr>
@@ -885,7 +886,7 @@
       </p:grpSpPr>
       <p:sp>
         <p:nvSpPr>
-          <p:cNvPr id="2" name="Slide Image Placeholder 1"/>
+          <p:cNvPr id="2089146933" name="Slide Image Placeholder 1"/>
           <p:cNvSpPr>
             <a:spLocks noChangeAspect="1" noGrp="1" noRot="1"/>
           </p:cNvSpPr>
@@ -897,7 +898,7 @@
       </p:sp>
       <p:sp>
         <p:nvSpPr>
-          <p:cNvPr id="3" name="Notes Placeholder 2"/>
+          <p:cNvPr id="1729284825" name="Notes Placeholder 2"/>
           <p:cNvSpPr>
             <a:spLocks noGrp="1"/>
           </p:cNvSpPr>
@@ -919,7 +920,7 @@
       </p:sp>
       <p:sp>
         <p:nvSpPr>
-          <p:cNvPr id="4" name="Slide Number Placeholder 3"/>
+          <p:cNvPr id="1334170577" name="Slide Number Placeholder 3"/>
           <p:cNvSpPr>
             <a:spLocks noGrp="1"/>
           </p:cNvSpPr>
@@ -970,7 +971,7 @@
       </p:grpSpPr>
       <p:sp>
         <p:nvSpPr>
-          <p:cNvPr id="2" name="Slide Image Placeholder 1"/>
+          <p:cNvPr id="53375955" name="Slide Image Placeholder 1"/>
           <p:cNvSpPr>
             <a:spLocks noChangeAspect="1" noGrp="1" noRot="1"/>
           </p:cNvSpPr>
@@ -982,7 +983,7 @@
       </p:sp>
       <p:sp>
         <p:nvSpPr>
-          <p:cNvPr id="3" name="Notes Placeholder 2"/>
+          <p:cNvPr id="1609413315" name="Notes Placeholder 2"/>
           <p:cNvSpPr>
             <a:spLocks noGrp="1"/>
           </p:cNvSpPr>
@@ -1004,7 +1005,7 @@
       </p:sp>
       <p:sp>
         <p:nvSpPr>
-          <p:cNvPr id="4" name="Slide Number Placeholder 3"/>
+          <p:cNvPr id="2066893882" name="Slide Number Placeholder 3"/>
           <p:cNvSpPr>
             <a:spLocks noGrp="1"/>
           </p:cNvSpPr>
@@ -1055,7 +1056,7 @@
       </p:grpSpPr>
       <p:sp>
         <p:nvSpPr>
-          <p:cNvPr id="2" name="Slide Image Placeholder 1"/>
+          <p:cNvPr id="878204071" name="Slide Image Placeholder 1"/>
           <p:cNvSpPr>
             <a:spLocks noChangeAspect="1" noGrp="1" noRot="1"/>
           </p:cNvSpPr>
@@ -1067,7 +1068,7 @@
       </p:sp>
       <p:sp>
         <p:nvSpPr>
-          <p:cNvPr id="3" name="Notes Placeholder 2"/>
+          <p:cNvPr id="28180847" name="Notes Placeholder 2"/>
           <p:cNvSpPr>
             <a:spLocks noGrp="1"/>
           </p:cNvSpPr>
@@ -1089,7 +1090,7 @@
       </p:sp>
       <p:sp>
         <p:nvSpPr>
-          <p:cNvPr id="4" name="Slide Number Placeholder 3"/>
+          <p:cNvPr id="64326243" name="Slide Number Placeholder 3"/>
           <p:cNvSpPr>
             <a:spLocks noGrp="1"/>
           </p:cNvSpPr>
@@ -1140,7 +1141,7 @@
       </p:grpSpPr>
       <p:sp>
         <p:nvSpPr>
-          <p:cNvPr id="2" name="Slide Image Placeholder 1"/>
+          <p:cNvPr id="1294885400" name="Slide Image Placeholder 1"/>
           <p:cNvSpPr>
             <a:spLocks noChangeAspect="1" noGrp="1" noRot="1"/>
           </p:cNvSpPr>
@@ -1152,7 +1153,7 @@
       </p:sp>
       <p:sp>
         <p:nvSpPr>
-          <p:cNvPr id="3" name="Notes Placeholder 2"/>
+          <p:cNvPr id="2015614565" name="Notes Placeholder 2"/>
           <p:cNvSpPr>
             <a:spLocks noGrp="1"/>
           </p:cNvSpPr>
@@ -1174,7 +1175,7 @@
       </p:sp>
       <p:sp>
         <p:nvSpPr>
-          <p:cNvPr id="4" name="Slide Number Placeholder 3"/>
+          <p:cNvPr id="1288029182" name="Slide Number Placeholder 3"/>
           <p:cNvSpPr>
             <a:spLocks noGrp="1"/>
           </p:cNvSpPr>
@@ -1225,7 +1226,7 @@
       </p:grpSpPr>
       <p:sp>
         <p:nvSpPr>
-          <p:cNvPr id="2" name="Slide Image Placeholder 1"/>
+          <p:cNvPr id="1156946003" name="Slide Image Placeholder 1"/>
           <p:cNvSpPr>
             <a:spLocks noChangeAspect="1" noGrp="1" noRot="1"/>
           </p:cNvSpPr>
@@ -1237,7 +1238,7 @@
       </p:sp>
       <p:sp>
         <p:nvSpPr>
-          <p:cNvPr id="3" name="Notes Placeholder 2"/>
+          <p:cNvPr id="623955895" name="Notes Placeholder 2"/>
           <p:cNvSpPr>
             <a:spLocks noGrp="1"/>
           </p:cNvSpPr>
@@ -1259,7 +1260,7 @@
       </p:sp>
       <p:sp>
         <p:nvSpPr>
-          <p:cNvPr id="4" name="Slide Number Placeholder 3"/>
+          <p:cNvPr id="1857859418" name="Slide Number Placeholder 3"/>
           <p:cNvSpPr>
             <a:spLocks noGrp="1"/>
           </p:cNvSpPr>
@@ -1310,7 +1311,7 @@
       </p:grpSpPr>
       <p:sp>
         <p:nvSpPr>
-          <p:cNvPr id="2" name="Slide Image Placeholder 1"/>
+          <p:cNvPr id="1786003311" name="Slide Image Placeholder 1"/>
           <p:cNvSpPr>
             <a:spLocks noChangeAspect="1" noGrp="1" noRot="1"/>
           </p:cNvSpPr>
@@ -1322,7 +1323,7 @@
       </p:sp>
       <p:sp>
         <p:nvSpPr>
-          <p:cNvPr id="3" name="Notes Placeholder 2"/>
+          <p:cNvPr id="1604268884" name="Notes Placeholder 2"/>
           <p:cNvSpPr>
             <a:spLocks noGrp="1"/>
           </p:cNvSpPr>
@@ -1344,7 +1345,7 @@
       </p:sp>
       <p:sp>
         <p:nvSpPr>
-          <p:cNvPr id="4" name="Slide Number Placeholder 3"/>
+          <p:cNvPr id="1547447218" name="Slide Number Placeholder 3"/>
           <p:cNvSpPr>
             <a:spLocks noGrp="1"/>
           </p:cNvSpPr>
@@ -1395,7 +1396,7 @@
       </p:grpSpPr>
       <p:sp>
         <p:nvSpPr>
-          <p:cNvPr id="2" name="Slide Image Placeholder 1"/>
+          <p:cNvPr id="788034267" name="Slide Image Placeholder 1"/>
           <p:cNvSpPr>
             <a:spLocks noChangeAspect="1" noGrp="1" noRot="1"/>
           </p:cNvSpPr>
@@ -1407,7 +1408,7 @@
       </p:sp>
       <p:sp>
         <p:nvSpPr>
-          <p:cNvPr id="3" name="Notes Placeholder 2"/>
+          <p:cNvPr id="798851846" name="Notes Placeholder 2"/>
           <p:cNvSpPr>
             <a:spLocks noGrp="1"/>
           </p:cNvSpPr>
@@ -1429,7 +1430,7 @@
       </p:sp>
       <p:sp>
         <p:nvSpPr>
-          <p:cNvPr id="4" name="Slide Number Placeholder 3"/>
+          <p:cNvPr id="1477228522" name="Slide Number Placeholder 3"/>
           <p:cNvSpPr>
             <a:spLocks noGrp="1"/>
           </p:cNvSpPr>
@@ -1480,7 +1481,7 @@
       </p:grpSpPr>
       <p:sp>
         <p:nvSpPr>
-          <p:cNvPr id="192037433" name="Title 1"/>
+          <p:cNvPr id="564733027" name="Title 1"/>
           <p:cNvSpPr>
             <a:spLocks noGrp="1"/>
           </p:cNvSpPr>
@@ -1511,7 +1512,7 @@
       </p:sp>
       <p:sp>
         <p:nvSpPr>
-          <p:cNvPr id="1274675853" name="Subtitle 2"/>
+          <p:cNvPr id="858123707" name="Subtitle 2"/>
           <p:cNvSpPr>
             <a:spLocks noGrp="1"/>
           </p:cNvSpPr>
@@ -1633,7 +1634,7 @@
       </p:sp>
       <p:sp>
         <p:nvSpPr>
-          <p:cNvPr id="1114125471" name="Date Placeholder 3"/>
+          <p:cNvPr id="738563773" name="Date Placeholder 3"/>
           <p:cNvSpPr>
             <a:spLocks noGrp="1"/>
           </p:cNvSpPr>
@@ -1659,7 +1660,7 @@
       </p:sp>
       <p:sp>
         <p:nvSpPr>
-          <p:cNvPr id="962982322" name="Footer Placeholder 4"/>
+          <p:cNvPr id="1239693925" name="Footer Placeholder 4"/>
           <p:cNvSpPr>
             <a:spLocks noGrp="1"/>
           </p:cNvSpPr>
@@ -1681,7 +1682,7 @@
       </p:sp>
       <p:sp>
         <p:nvSpPr>
-          <p:cNvPr id="1680109241" name="Slide Number Placeholder 5"/>
+          <p:cNvPr id="1468783408" name="Slide Number Placeholder 5"/>
           <p:cNvSpPr>
             <a:spLocks noGrp="1"/>
           </p:cNvSpPr>
@@ -1732,7 +1733,7 @@
       </p:grpSpPr>
       <p:sp>
         <p:nvSpPr>
-          <p:cNvPr id="1732042427" name="Title 1"/>
+          <p:cNvPr id="565006736" name="Title 1"/>
           <p:cNvSpPr>
             <a:spLocks noGrp="1"/>
           </p:cNvSpPr>
@@ -1758,7 +1759,7 @@
       </p:sp>
       <p:sp>
         <p:nvSpPr>
-          <p:cNvPr id="1552373076" name="Vertical Text Placeholder 2"/>
+          <p:cNvPr id="1876789063" name="Vertical Text Placeholder 2"/>
           <p:cNvSpPr>
             <a:spLocks noGrp="1"/>
           </p:cNvSpPr>
@@ -1824,7 +1825,7 @@
       </p:sp>
       <p:sp>
         <p:nvSpPr>
-          <p:cNvPr id="1532392900" name="Date Placeholder 3"/>
+          <p:cNvPr id="1323467013" name="Date Placeholder 3"/>
           <p:cNvSpPr>
             <a:spLocks noGrp="1"/>
           </p:cNvSpPr>
@@ -1850,7 +1851,7 @@
       </p:sp>
       <p:sp>
         <p:nvSpPr>
-          <p:cNvPr id="1976239491" name="Footer Placeholder 4"/>
+          <p:cNvPr id="346872787" name="Footer Placeholder 4"/>
           <p:cNvSpPr>
             <a:spLocks noGrp="1"/>
           </p:cNvSpPr>
@@ -1872,7 +1873,7 @@
       </p:sp>
       <p:sp>
         <p:nvSpPr>
-          <p:cNvPr id="815688732" name="Slide Number Placeholder 5"/>
+          <p:cNvPr id="1158998005" name="Slide Number Placeholder 5"/>
           <p:cNvSpPr>
             <a:spLocks noGrp="1"/>
           </p:cNvSpPr>
@@ -1923,7 +1924,7 @@
       </p:grpSpPr>
       <p:sp>
         <p:nvSpPr>
-          <p:cNvPr id="856193140" name="Vertical Title 1"/>
+          <p:cNvPr id="966506624" name="Vertical Title 1"/>
           <p:cNvSpPr>
             <a:spLocks noGrp="1"/>
           </p:cNvSpPr>
@@ -1954,7 +1955,7 @@
       </p:sp>
       <p:sp>
         <p:nvSpPr>
-          <p:cNvPr id="944940135" name="Vertical Text Placeholder 2"/>
+          <p:cNvPr id="1207993223" name="Vertical Text Placeholder 2"/>
           <p:cNvSpPr>
             <a:spLocks noGrp="1"/>
           </p:cNvSpPr>
@@ -2025,7 +2026,7 @@
       </p:sp>
       <p:sp>
         <p:nvSpPr>
-          <p:cNvPr id="1400940902" name="Date Placeholder 3"/>
+          <p:cNvPr id="1613238037" name="Date Placeholder 3"/>
           <p:cNvSpPr>
             <a:spLocks noGrp="1"/>
           </p:cNvSpPr>
@@ -2051,7 +2052,7 @@
       </p:sp>
       <p:sp>
         <p:nvSpPr>
-          <p:cNvPr id="1396444354" name="Footer Placeholder 4"/>
+          <p:cNvPr id="1023663181" name="Footer Placeholder 4"/>
           <p:cNvSpPr>
             <a:spLocks noGrp="1"/>
           </p:cNvSpPr>
@@ -2073,7 +2074,7 @@
       </p:sp>
       <p:sp>
         <p:nvSpPr>
-          <p:cNvPr id="423688870" name="Slide Number Placeholder 5"/>
+          <p:cNvPr id="348323542" name="Slide Number Placeholder 5"/>
           <p:cNvSpPr>
             <a:spLocks noGrp="1"/>
           </p:cNvSpPr>
@@ -2124,7 +2125,7 @@
       </p:grpSpPr>
       <p:sp>
         <p:nvSpPr>
-          <p:cNvPr id="857865518" name="Title 1"/>
+          <p:cNvPr id="120704139" name="Title 1"/>
           <p:cNvSpPr>
             <a:spLocks noGrp="1"/>
           </p:cNvSpPr>
@@ -2150,7 +2151,7 @@
       </p:sp>
       <p:sp>
         <p:nvSpPr>
-          <p:cNvPr id="1065366817" name="Content Placeholder 2"/>
+          <p:cNvPr id="363120903" name="Content Placeholder 2"/>
           <p:cNvSpPr>
             <a:spLocks noGrp="1"/>
           </p:cNvSpPr>
@@ -2216,7 +2217,7 @@
       </p:sp>
       <p:sp>
         <p:nvSpPr>
-          <p:cNvPr id="1467790260" name="Date Placeholder 3"/>
+          <p:cNvPr id="279480607" name="Date Placeholder 3"/>
           <p:cNvSpPr>
             <a:spLocks noGrp="1"/>
           </p:cNvSpPr>
@@ -2242,7 +2243,7 @@
       </p:sp>
       <p:sp>
         <p:nvSpPr>
-          <p:cNvPr id="1044392532" name="Footer Placeholder 4"/>
+          <p:cNvPr id="1244750828" name="Footer Placeholder 4"/>
           <p:cNvSpPr>
             <a:spLocks noGrp="1"/>
           </p:cNvSpPr>
@@ -2264,7 +2265,7 @@
       </p:sp>
       <p:sp>
         <p:nvSpPr>
-          <p:cNvPr id="51292776" name="Slide Number Placeholder 5"/>
+          <p:cNvPr id="577375626" name="Slide Number Placeholder 5"/>
           <p:cNvSpPr>
             <a:spLocks noGrp="1"/>
           </p:cNvSpPr>
@@ -2315,7 +2316,7 @@
       </p:grpSpPr>
       <p:sp>
         <p:nvSpPr>
-          <p:cNvPr id="1079939912" name="Title 1"/>
+          <p:cNvPr id="1104890376" name="Title 1"/>
           <p:cNvSpPr>
             <a:spLocks noGrp="1"/>
           </p:cNvSpPr>
@@ -2350,7 +2351,7 @@
       </p:sp>
       <p:sp>
         <p:nvSpPr>
-          <p:cNvPr id="223325602" name="Text Placeholder 2"/>
+          <p:cNvPr id="1408515847" name="Text Placeholder 2"/>
           <p:cNvSpPr>
             <a:spLocks noGrp="1"/>
           </p:cNvSpPr>
@@ -2472,7 +2473,7 @@
       </p:sp>
       <p:sp>
         <p:nvSpPr>
-          <p:cNvPr id="1844284091" name="Date Placeholder 3"/>
+          <p:cNvPr id="1350820215" name="Date Placeholder 3"/>
           <p:cNvSpPr>
             <a:spLocks noGrp="1"/>
           </p:cNvSpPr>
@@ -2498,7 +2499,7 @@
       </p:sp>
       <p:sp>
         <p:nvSpPr>
-          <p:cNvPr id="889626987" name="Footer Placeholder 4"/>
+          <p:cNvPr id="1684553376" name="Footer Placeholder 4"/>
           <p:cNvSpPr>
             <a:spLocks noGrp="1"/>
           </p:cNvSpPr>
@@ -2520,7 +2521,7 @@
       </p:sp>
       <p:sp>
         <p:nvSpPr>
-          <p:cNvPr id="1405724481" name="Slide Number Placeholder 5"/>
+          <p:cNvPr id="674410588" name="Slide Number Placeholder 5"/>
           <p:cNvSpPr>
             <a:spLocks noGrp="1"/>
           </p:cNvSpPr>
@@ -2571,7 +2572,7 @@
       </p:grpSpPr>
       <p:sp>
         <p:nvSpPr>
-          <p:cNvPr id="679201137" name="Title 1"/>
+          <p:cNvPr id="1570703185" name="Title 1"/>
           <p:cNvSpPr>
             <a:spLocks noGrp="1"/>
           </p:cNvSpPr>
@@ -2597,7 +2598,7 @@
       </p:sp>
       <p:sp>
         <p:nvSpPr>
-          <p:cNvPr id="854214431" name="Content Placeholder 2"/>
+          <p:cNvPr id="2070487359" name="Content Placeholder 2"/>
           <p:cNvSpPr>
             <a:spLocks noGrp="1"/>
           </p:cNvSpPr>
@@ -2696,7 +2697,7 @@
       </p:sp>
       <p:sp>
         <p:nvSpPr>
-          <p:cNvPr id="1286006722" name="Content Placeholder 3"/>
+          <p:cNvPr id="936127443" name="Content Placeholder 3"/>
           <p:cNvSpPr>
             <a:spLocks noGrp="1"/>
           </p:cNvSpPr>
@@ -2795,7 +2796,7 @@
       </p:sp>
       <p:sp>
         <p:nvSpPr>
-          <p:cNvPr id="866809808" name="Date Placeholder 4"/>
+          <p:cNvPr id="1258805392" name="Date Placeholder 4"/>
           <p:cNvSpPr>
             <a:spLocks noGrp="1"/>
           </p:cNvSpPr>
@@ -2821,7 +2822,7 @@
       </p:sp>
       <p:sp>
         <p:nvSpPr>
-          <p:cNvPr id="607299590" name="Footer Placeholder 5"/>
+          <p:cNvPr id="73642841" name="Footer Placeholder 5"/>
           <p:cNvSpPr>
             <a:spLocks noGrp="1"/>
           </p:cNvSpPr>
@@ -2843,7 +2844,7 @@
       </p:sp>
       <p:sp>
         <p:nvSpPr>
-          <p:cNvPr id="241308698" name="Slide Number Placeholder 6"/>
+          <p:cNvPr id="422216416" name="Slide Number Placeholder 6"/>
           <p:cNvSpPr>
             <a:spLocks noGrp="1"/>
           </p:cNvSpPr>
@@ -2894,7 +2895,7 @@
       </p:grpSpPr>
       <p:sp>
         <p:nvSpPr>
-          <p:cNvPr id="1590156286" name="Title 1"/>
+          <p:cNvPr id="1530493572" name="Title 1"/>
           <p:cNvSpPr>
             <a:spLocks noGrp="1"/>
           </p:cNvSpPr>
@@ -2924,7 +2925,7 @@
       </p:sp>
       <p:sp>
         <p:nvSpPr>
-          <p:cNvPr id="1113528626" name="Text Placeholder 2"/>
+          <p:cNvPr id="315309228" name="Text Placeholder 2"/>
           <p:cNvSpPr>
             <a:spLocks noGrp="1"/>
           </p:cNvSpPr>
@@ -2992,7 +2993,7 @@
       </p:sp>
       <p:sp>
         <p:nvSpPr>
-          <p:cNvPr id="1604347175" name="Content Placeholder 3"/>
+          <p:cNvPr id="541586433" name="Content Placeholder 3"/>
           <p:cNvSpPr>
             <a:spLocks noGrp="1"/>
           </p:cNvSpPr>
@@ -3091,7 +3092,7 @@
       </p:sp>
       <p:sp>
         <p:nvSpPr>
-          <p:cNvPr id="1809689062" name="Text Placeholder 4"/>
+          <p:cNvPr id="1208714520" name="Text Placeholder 4"/>
           <p:cNvSpPr>
             <a:spLocks noGrp="1"/>
           </p:cNvSpPr>
@@ -3159,7 +3160,7 @@
       </p:sp>
       <p:sp>
         <p:nvSpPr>
-          <p:cNvPr id="1120373424" name="Content Placeholder 5"/>
+          <p:cNvPr id="1810794420" name="Content Placeholder 5"/>
           <p:cNvSpPr>
             <a:spLocks noGrp="1"/>
           </p:cNvSpPr>
@@ -3258,7 +3259,7 @@
       </p:sp>
       <p:sp>
         <p:nvSpPr>
-          <p:cNvPr id="888963164" name="Date Placeholder 6"/>
+          <p:cNvPr id="699566540" name="Date Placeholder 6"/>
           <p:cNvSpPr>
             <a:spLocks noGrp="1"/>
           </p:cNvSpPr>
@@ -3284,7 +3285,7 @@
       </p:sp>
       <p:sp>
         <p:nvSpPr>
-          <p:cNvPr id="1693989396" name="Footer Placeholder 7"/>
+          <p:cNvPr id="2141650430" name="Footer Placeholder 7"/>
           <p:cNvSpPr>
             <a:spLocks noGrp="1"/>
           </p:cNvSpPr>
@@ -3306,7 +3307,7 @@
       </p:sp>
       <p:sp>
         <p:nvSpPr>
-          <p:cNvPr id="203202745" name="Slide Number Placeholder 8"/>
+          <p:cNvPr id="72871110" name="Slide Number Placeholder 8"/>
           <p:cNvSpPr>
             <a:spLocks noGrp="1"/>
           </p:cNvSpPr>
@@ -3357,7 +3358,7 @@
       </p:grpSpPr>
       <p:sp>
         <p:nvSpPr>
-          <p:cNvPr id="227720906" name="Title 1"/>
+          <p:cNvPr id="28742429" name="Title 1"/>
           <p:cNvSpPr>
             <a:spLocks noGrp="1"/>
           </p:cNvSpPr>
@@ -3383,7 +3384,7 @@
       </p:sp>
       <p:sp>
         <p:nvSpPr>
-          <p:cNvPr id="725920180" name="Date Placeholder 2"/>
+          <p:cNvPr id="1977558476" name="Date Placeholder 2"/>
           <p:cNvSpPr>
             <a:spLocks noGrp="1"/>
           </p:cNvSpPr>
@@ -3409,7 +3410,7 @@
       </p:sp>
       <p:sp>
         <p:nvSpPr>
-          <p:cNvPr id="1972064560" name="Footer Placeholder 3"/>
+          <p:cNvPr id="781038067" name="Footer Placeholder 3"/>
           <p:cNvSpPr>
             <a:spLocks noGrp="1"/>
           </p:cNvSpPr>
@@ -3431,7 +3432,7 @@
       </p:sp>
       <p:sp>
         <p:nvSpPr>
-          <p:cNvPr id="234318998" name="Slide Number Placeholder 4"/>
+          <p:cNvPr id="1264152537" name="Slide Number Placeholder 4"/>
           <p:cNvSpPr>
             <a:spLocks noGrp="1"/>
           </p:cNvSpPr>
@@ -3482,7 +3483,7 @@
       </p:grpSpPr>
       <p:sp>
         <p:nvSpPr>
-          <p:cNvPr id="2117952204" name="Date Placeholder 1"/>
+          <p:cNvPr id="1603680379" name="Date Placeholder 1"/>
           <p:cNvSpPr>
             <a:spLocks noGrp="1"/>
           </p:cNvSpPr>
@@ -3508,7 +3509,7 @@
       </p:sp>
       <p:sp>
         <p:nvSpPr>
-          <p:cNvPr id="1490439702" name="Footer Placeholder 2"/>
+          <p:cNvPr id="1479163502" name="Footer Placeholder 2"/>
           <p:cNvSpPr>
             <a:spLocks noGrp="1"/>
           </p:cNvSpPr>
@@ -3530,7 +3531,7 @@
       </p:sp>
       <p:sp>
         <p:nvSpPr>
-          <p:cNvPr id="544950583" name="Slide Number Placeholder 3"/>
+          <p:cNvPr id="672951017" name="Slide Number Placeholder 3"/>
           <p:cNvSpPr>
             <a:spLocks noGrp="1"/>
           </p:cNvSpPr>
@@ -3581,7 +3582,7 @@
       </p:grpSpPr>
       <p:sp>
         <p:nvSpPr>
-          <p:cNvPr id="1548008238" name="Title 1"/>
+          <p:cNvPr id="389488142" name="Title 1"/>
           <p:cNvSpPr>
             <a:spLocks noGrp="1"/>
           </p:cNvSpPr>
@@ -3616,7 +3617,7 @@
       </p:sp>
       <p:sp>
         <p:nvSpPr>
-          <p:cNvPr id="928730379" name="Content Placeholder 2"/>
+          <p:cNvPr id="1218619970" name="Content Placeholder 2"/>
           <p:cNvSpPr>
             <a:spLocks noGrp="1"/>
           </p:cNvSpPr>
@@ -3715,7 +3716,7 @@
       </p:sp>
       <p:sp>
         <p:nvSpPr>
-          <p:cNvPr id="186253138" name="Text Placeholder 3"/>
+          <p:cNvPr id="1744531470" name="Text Placeholder 3"/>
           <p:cNvSpPr>
             <a:spLocks noGrp="1"/>
           </p:cNvSpPr>
@@ -3783,7 +3784,7 @@
       </p:sp>
       <p:sp>
         <p:nvSpPr>
-          <p:cNvPr id="378770156" name="Date Placeholder 4"/>
+          <p:cNvPr id="834425641" name="Date Placeholder 4"/>
           <p:cNvSpPr>
             <a:spLocks noGrp="1"/>
           </p:cNvSpPr>
@@ -3809,7 +3810,7 @@
       </p:sp>
       <p:sp>
         <p:nvSpPr>
-          <p:cNvPr id="1502774065" name="Footer Placeholder 5"/>
+          <p:cNvPr id="1271245250" name="Footer Placeholder 5"/>
           <p:cNvSpPr>
             <a:spLocks noGrp="1"/>
           </p:cNvSpPr>
@@ -3831,7 +3832,7 @@
       </p:sp>
       <p:sp>
         <p:nvSpPr>
-          <p:cNvPr id="221960260" name="Slide Number Placeholder 6"/>
+          <p:cNvPr id="619038444" name="Slide Number Placeholder 6"/>
           <p:cNvSpPr>
             <a:spLocks noGrp="1"/>
           </p:cNvSpPr>
@@ -3882,7 +3883,7 @@
       </p:grpSpPr>
       <p:sp>
         <p:nvSpPr>
-          <p:cNvPr id="1443439052" name="Title 1"/>
+          <p:cNvPr id="1933263883" name="Title 1"/>
           <p:cNvSpPr>
             <a:spLocks noGrp="1"/>
           </p:cNvSpPr>
@@ -3917,7 +3918,7 @@
       </p:sp>
       <p:sp>
         <p:nvSpPr>
-          <p:cNvPr id="1955162905" name="Picture Placeholder 2"/>
+          <p:cNvPr id="492285942" name="Picture Placeholder 2"/>
           <p:cNvSpPr>
             <a:spLocks noGrp="1"/>
           </p:cNvSpPr>
@@ -3981,7 +3982,7 @@
       </p:sp>
       <p:sp>
         <p:nvSpPr>
-          <p:cNvPr id="309573068" name="Text Placeholder 3"/>
+          <p:cNvPr id="228876866" name="Text Placeholder 3"/>
           <p:cNvSpPr>
             <a:spLocks noGrp="1"/>
           </p:cNvSpPr>
@@ -4049,7 +4050,7 @@
       </p:sp>
       <p:sp>
         <p:nvSpPr>
-          <p:cNvPr id="1897259637" name="Date Placeholder 4"/>
+          <p:cNvPr id="1647355318" name="Date Placeholder 4"/>
           <p:cNvSpPr>
             <a:spLocks noGrp="1"/>
           </p:cNvSpPr>
@@ -4075,7 +4076,7 @@
       </p:sp>
       <p:sp>
         <p:nvSpPr>
-          <p:cNvPr id="2052276868" name="Footer Placeholder 5"/>
+          <p:cNvPr id="439777222" name="Footer Placeholder 5"/>
           <p:cNvSpPr>
             <a:spLocks noGrp="1"/>
           </p:cNvSpPr>
@@ -4097,7 +4098,7 @@
       </p:sp>
       <p:sp>
         <p:nvSpPr>
-          <p:cNvPr id="1663345813" name="Slide Number Placeholder 6"/>
+          <p:cNvPr id="1778917529" name="Slide Number Placeholder 6"/>
           <p:cNvSpPr>
             <a:spLocks noGrp="1"/>
           </p:cNvSpPr>
@@ -4153,7 +4154,7 @@
       </p:grpSpPr>
       <p:sp>
         <p:nvSpPr>
-          <p:cNvPr id="1502368214" name="Title Placeholder 1"/>
+          <p:cNvPr id="151075440" name="Title Placeholder 1"/>
           <p:cNvSpPr>
             <a:spLocks noGrp="1"/>
           </p:cNvSpPr>
@@ -4189,7 +4190,7 @@
       </p:sp>
       <p:sp>
         <p:nvSpPr>
-          <p:cNvPr id="876129070" name="Text Placeholder 2"/>
+          <p:cNvPr id="868060913" name="Text Placeholder 2"/>
           <p:cNvSpPr>
             <a:spLocks noGrp="1"/>
           </p:cNvSpPr>
@@ -4265,7 +4266,7 @@
       </p:sp>
       <p:sp>
         <p:nvSpPr>
-          <p:cNvPr id="880306657" name="Date Placeholder 3"/>
+          <p:cNvPr id="2066554634" name="Date Placeholder 3"/>
           <p:cNvSpPr>
             <a:spLocks noGrp="1"/>
           </p:cNvSpPr>
@@ -4309,7 +4310,7 @@
       </p:sp>
       <p:sp>
         <p:nvSpPr>
-          <p:cNvPr id="392236667" name="Footer Placeholder 4"/>
+          <p:cNvPr id="1410497452" name="Footer Placeholder 4"/>
           <p:cNvSpPr>
             <a:spLocks noGrp="1"/>
           </p:cNvSpPr>
@@ -4349,7 +4350,7 @@
       </p:sp>
       <p:sp>
         <p:nvSpPr>
-          <p:cNvPr id="1686343480" name="Slide Number Placeholder 5"/>
+          <p:cNvPr id="606494910" name="Slide Number Placeholder 5"/>
           <p:cNvSpPr>
             <a:spLocks noGrp="1"/>
           </p:cNvSpPr>
@@ -4407,6 +4408,7 @@
     <p:sldLayoutId id="2147483658" r:id="rId10"/>
     <p:sldLayoutId id="2147483659" r:id="rId11"/>
   </p:sldLayoutIdLst>
+  <p:hf dt="0" ftr="0" hdr="0" sldNum="1"/>
   <p:txStyles>
     <p:titleStyle>
       <a:lvl1pPr algn="ctr" defTabSz="457200" rtl="0">
@@ -4686,7 +4688,7 @@
       </p:grpSpPr>
       <p:pic>
         <p:nvPicPr>
-          <p:cNvPr id="1920352258" name="Picture 1" descr="image.png"/>
+          <p:cNvPr id="1949057050" name="Picture 1" descr="image.png"/>
           <p:cNvPicPr>
             <a:picLocks noChangeAspect="1"/>
           </p:cNvPicPr>
@@ -4708,7 +4710,7 @@
       </p:pic>
       <p:pic>
         <p:nvPicPr>
-          <p:cNvPr id="887631809" name="Picture 2" descr="image.png"/>
+          <p:cNvPr id="2023844461" name="Picture 2" descr="image.png"/>
           <p:cNvPicPr>
             <a:picLocks noChangeAspect="1"/>
           </p:cNvPicPr>
@@ -4730,7 +4732,7 @@
       </p:pic>
       <p:pic>
         <p:nvPicPr>
-          <p:cNvPr id="1628120548" name="Picture 3" descr="image.png"/>
+          <p:cNvPr id="326768404" name="Picture 3" descr="image.png"/>
           <p:cNvPicPr>
             <a:picLocks noChangeAspect="1"/>
           </p:cNvPicPr>
@@ -4752,7 +4754,7 @@
       </p:pic>
       <p:sp>
         <p:nvSpPr>
-          <p:cNvPr id="561035479" name="TextBox 4"/>
+          <p:cNvPr id="1036194741" name="TextBox 4"/>
           <p:cNvSpPr txBox="1"/>
           <p:nvPr/>
         </p:nvSpPr>
@@ -4798,7 +4800,7 @@
       </p:sp>
       <p:sp>
         <p:nvSpPr>
-          <p:cNvPr id="1622568975" name="TextBox 5"/>
+          <p:cNvPr id="2142489368" name="TextBox 5"/>
           <p:cNvSpPr txBox="1"/>
           <p:nvPr/>
         </p:nvSpPr>
@@ -4839,7 +4841,7 @@
       </p:sp>
       <p:sp>
         <p:nvSpPr>
-          <p:cNvPr id="174172888" name="TextBox 6"/>
+          <p:cNvPr id="465698654" name="TextBox 6"/>
           <p:cNvSpPr txBox="1"/>
           <p:nvPr/>
         </p:nvSpPr>
@@ -4877,7 +4879,7 @@
       </p:sp>
       <p:sp>
         <p:nvSpPr>
-          <p:cNvPr id="1478373012" name="TextBox 7"/>
+          <p:cNvPr id="393218745" name="TextBox 7"/>
           <p:cNvSpPr txBox="1"/>
           <p:nvPr/>
         </p:nvSpPr>
@@ -4915,7 +4917,7 @@
       </p:sp>
       <p:sp>
         <p:nvSpPr>
-          <p:cNvPr id="463845852" name="TextBox 8"/>
+          <p:cNvPr id="1537882967" name="TextBox 8"/>
           <p:cNvSpPr txBox="1"/>
           <p:nvPr/>
         </p:nvSpPr>
@@ -4953,7 +4955,7 @@
       </p:sp>
       <p:sp>
         <p:nvSpPr>
-          <p:cNvPr id="226665588" name="TextBox 9"/>
+          <p:cNvPr id="997042945" name="TextBox 9"/>
           <p:cNvSpPr txBox="1"/>
           <p:nvPr/>
         </p:nvSpPr>
@@ -5005,7 +5007,7 @@
       </p:sp>
       <p:sp>
         <p:nvSpPr>
-          <p:cNvPr id="1660055664" name="TextBox 10"/>
+          <p:cNvPr id="126053842" name="TextBox 10"/>
           <p:cNvSpPr txBox="1"/>
           <p:nvPr/>
         </p:nvSpPr>
@@ -5043,7 +5045,7 @@
       </p:sp>
       <p:sp>
         <p:nvSpPr>
-          <p:cNvPr id="728016690" name="TextBox 11"/>
+          <p:cNvPr id="614344248" name="TextBox 11"/>
           <p:cNvSpPr txBox="1"/>
           <p:nvPr/>
         </p:nvSpPr>
@@ -5075,6 +5077,32 @@
               </a:rPr>
               <a:t>C++17 / Qt6 / CMake</a:t>
             </a:r>
+            <a:endParaRPr/>
+          </a:p>
+        </p:txBody>
+      </p:sp>
+      <p:sp>
+        <p:nvSpPr>
+          <p:cNvPr id="446132857" name="Slide Number Placeholder 3"/>
+          <p:cNvSpPr>
+            <a:spLocks noGrp="1"/>
+          </p:cNvSpPr>
+          <p:nvPr>
+            <p:ph type="sldNum" sz="quarter" idx="12"/>
+          </p:nvPr>
+        </p:nvSpPr>
+        <p:spPr bwMode="auto"/>
+        <p:txBody>
+          <a:bodyPr/>
+          <a:lstStyle/>
+          <a:p>
+            <a:pPr>
+              <a:defRPr/>
+            </a:pPr>
+            <a:fld id="{A72A9C10-3FC1-7749-74E9-57BEC53CFBB9}" type="slidenum">
+              <a:rPr lang="en-US"/>
+              <a:t>1</a:t>
+            </a:fld>
             <a:endParaRPr/>
           </a:p>
         </p:txBody>
@@ -5121,7 +5149,7 @@
       </p:grpSpPr>
       <p:pic>
         <p:nvPicPr>
-          <p:cNvPr id="1705673897" name="Picture 1" descr="image.png"/>
+          <p:cNvPr id="1413812235" name="Picture 1" descr="image.png"/>
           <p:cNvPicPr>
             <a:picLocks noChangeAspect="1"/>
           </p:cNvPicPr>
@@ -5143,7 +5171,7 @@
       </p:pic>
       <p:pic>
         <p:nvPicPr>
-          <p:cNvPr id="969406411" name="Picture 2" descr="image.png"/>
+          <p:cNvPr id="443756796" name="Picture 2" descr="image.png"/>
           <p:cNvPicPr>
             <a:picLocks noChangeAspect="1"/>
           </p:cNvPicPr>
@@ -5165,7 +5193,7 @@
       </p:pic>
       <p:pic>
         <p:nvPicPr>
-          <p:cNvPr id="901566359" name="Picture 3" descr="image.png"/>
+          <p:cNvPr id="1493481011" name="Picture 3" descr="image.png"/>
           <p:cNvPicPr>
             <a:picLocks noChangeAspect="1"/>
           </p:cNvPicPr>
@@ -5187,7 +5215,7 @@
       </p:pic>
       <p:pic>
         <p:nvPicPr>
-          <p:cNvPr id="311453560" name="Picture 6" descr="image.png"/>
+          <p:cNvPr id="288489149" name="Picture 6" descr="image.png"/>
           <p:cNvPicPr>
             <a:picLocks noChangeAspect="1"/>
           </p:cNvPicPr>
@@ -5209,7 +5237,7 @@
       </p:pic>
       <p:sp>
         <p:nvSpPr>
-          <p:cNvPr id="1143416618" name="TextBox 7"/>
+          <p:cNvPr id="803554834" name="TextBox 7"/>
           <p:cNvSpPr txBox="1"/>
           <p:nvPr/>
         </p:nvSpPr>
@@ -5247,7 +5275,7 @@
       </p:sp>
       <p:sp>
         <p:nvSpPr>
-          <p:cNvPr id="514236478" name="TextBox 8"/>
+          <p:cNvPr id="1882436674" name="TextBox 8"/>
           <p:cNvSpPr txBox="1"/>
           <p:nvPr/>
         </p:nvSpPr>
@@ -5347,7 +5375,7 @@
       </p:sp>
       <p:sp>
         <p:nvSpPr>
-          <p:cNvPr id="176297553" name="TextBox 9"/>
+          <p:cNvPr id="103210115" name="TextBox 9"/>
           <p:cNvSpPr txBox="1"/>
           <p:nvPr/>
         </p:nvSpPr>
@@ -5397,7 +5425,7 @@
       </p:sp>
       <p:sp>
         <p:nvSpPr>
-          <p:cNvPr id="1685852867" name="TextBox 10"/>
+          <p:cNvPr id="597824890" name="TextBox 10"/>
           <p:cNvSpPr txBox="1"/>
           <p:nvPr/>
         </p:nvSpPr>
@@ -5435,7 +5463,7 @@
       </p:sp>
       <p:sp>
         <p:nvSpPr>
-          <p:cNvPr id="202472424" name="TextBox 11"/>
+          <p:cNvPr id="568454792" name="TextBox 11"/>
           <p:cNvSpPr txBox="1"/>
           <p:nvPr/>
         </p:nvSpPr>
@@ -5485,7 +5513,7 @@
       </p:sp>
       <p:sp>
         <p:nvSpPr>
-          <p:cNvPr id="515633219" name="TextBox 12"/>
+          <p:cNvPr id="1933780284" name="TextBox 12"/>
           <p:cNvSpPr txBox="1"/>
           <p:nvPr/>
         </p:nvSpPr>
@@ -5535,7 +5563,7 @@
       </p:sp>
       <p:pic>
         <p:nvPicPr>
-          <p:cNvPr id="1911103365" name="Picture 19" descr="image.png"/>
+          <p:cNvPr id="2106751846" name="Picture 19" descr="image.png"/>
           <p:cNvPicPr>
             <a:picLocks noChangeAspect="1"/>
           </p:cNvPicPr>
@@ -5557,7 +5585,7 @@
       </p:pic>
       <p:pic>
         <p:nvPicPr>
-          <p:cNvPr id="1319835975" name="Picture 20" descr="image.png"/>
+          <p:cNvPr id="594253847" name="Picture 20" descr="image.png"/>
           <p:cNvPicPr>
             <a:picLocks noChangeAspect="1"/>
           </p:cNvPicPr>
@@ -5579,7 +5607,7 @@
       </p:pic>
       <p:sp>
         <p:nvSpPr>
-          <p:cNvPr id="145364047" name="TextBox 21"/>
+          <p:cNvPr id="462037857" name="TextBox 21"/>
           <p:cNvSpPr txBox="1"/>
           <p:nvPr/>
         </p:nvSpPr>
@@ -5617,7 +5645,7 @@
       </p:sp>
       <p:pic>
         <p:nvPicPr>
-          <p:cNvPr id="750297925" name="Picture 27" descr="image.png"/>
+          <p:cNvPr id="1967840252" name="Picture 27" descr="image.png"/>
           <p:cNvPicPr>
             <a:picLocks noChangeAspect="1"/>
           </p:cNvPicPr>
@@ -5639,7 +5667,7 @@
       </p:pic>
       <p:pic>
         <p:nvPicPr>
-          <p:cNvPr id="887778858" name="Graphic 22"/>
+          <p:cNvPr id="1418627632" name="Graphic 22"/>
           <p:cNvPicPr>
             <a:picLocks noChangeAspect="1"/>
           </p:cNvPicPr>
@@ -5667,7 +5695,7 @@
       </p:pic>
       <p:sp>
         <p:nvSpPr>
-          <p:cNvPr id="1505723486" name="TextBox 14"/>
+          <p:cNvPr id="690272675" name="TextBox 14"/>
           <p:cNvSpPr txBox="1"/>
           <p:nvPr/>
         </p:nvSpPr>
@@ -5705,7 +5733,7 @@
       </p:sp>
       <p:sp>
         <p:nvSpPr>
-          <p:cNvPr id="103615113" name="TextBox 15"/>
+          <p:cNvPr id="1457641021" name="TextBox 15"/>
           <p:cNvSpPr txBox="1"/>
           <p:nvPr/>
         </p:nvSpPr>
@@ -5793,6 +5821,32 @@
               <a:ea typeface="Calibri"/>
               <a:cs typeface="Calibri"/>
             </a:endParaRPr>
+          </a:p>
+        </p:txBody>
+      </p:sp>
+      <p:sp>
+        <p:nvSpPr>
+          <p:cNvPr id="931490607" name="Slide Number Placeholder 3"/>
+          <p:cNvSpPr>
+            <a:spLocks noGrp="1"/>
+          </p:cNvSpPr>
+          <p:nvPr>
+            <p:ph type="sldNum" sz="quarter" idx="12"/>
+          </p:nvPr>
+        </p:nvSpPr>
+        <p:spPr bwMode="auto"/>
+        <p:txBody>
+          <a:bodyPr/>
+          <a:lstStyle/>
+          <a:p>
+            <a:pPr>
+              <a:defRPr/>
+            </a:pPr>
+            <a:fld id="{218163E2-B399-50AC-717E-CED1D171DCB3}" type="slidenum">
+              <a:rPr lang="en-US"/>
+              <a:t>1</a:t>
+            </a:fld>
+            <a:endParaRPr/>
           </a:p>
         </p:txBody>
       </p:sp>
@@ -5838,7 +5892,7 @@
       </p:grpSpPr>
       <p:pic>
         <p:nvPicPr>
-          <p:cNvPr id="980487626" name="Picture 1" descr="image.png"/>
+          <p:cNvPr id="1651193712" name="Picture 1" descr="image.png"/>
           <p:cNvPicPr>
             <a:picLocks noChangeAspect="1"/>
           </p:cNvPicPr>
@@ -5860,7 +5914,7 @@
       </p:pic>
       <p:pic>
         <p:nvPicPr>
-          <p:cNvPr id="256420490" name="Picture 2" descr="image.png"/>
+          <p:cNvPr id="2076721675" name="Picture 2" descr="image.png"/>
           <p:cNvPicPr>
             <a:picLocks noChangeAspect="1"/>
           </p:cNvPicPr>
@@ -5882,7 +5936,7 @@
       </p:pic>
       <p:pic>
         <p:nvPicPr>
-          <p:cNvPr id="274187499" name="Picture 3" descr="image.png"/>
+          <p:cNvPr id="96803698" name="Picture 3" descr="image.png"/>
           <p:cNvPicPr>
             <a:picLocks noChangeAspect="1"/>
           </p:cNvPicPr>
@@ -5904,7 +5958,7 @@
       </p:pic>
       <p:sp>
         <p:nvSpPr>
-          <p:cNvPr id="1102928690" name="TextBox 4"/>
+          <p:cNvPr id="683593394" name="TextBox 4"/>
           <p:cNvSpPr txBox="1"/>
           <p:nvPr/>
         </p:nvSpPr>
@@ -5945,7 +5999,7 @@
       </p:sp>
       <p:sp>
         <p:nvSpPr>
-          <p:cNvPr id="295531880" name="TextBox 5"/>
+          <p:cNvPr id="1612392246" name="TextBox 5"/>
           <p:cNvSpPr txBox="1"/>
           <p:nvPr/>
         </p:nvSpPr>
@@ -5983,7 +6037,7 @@
       </p:sp>
       <p:sp>
         <p:nvSpPr>
-          <p:cNvPr id="1880748656" name="TextBox 6"/>
+          <p:cNvPr id="1365375311" name="TextBox 6"/>
           <p:cNvSpPr txBox="1"/>
           <p:nvPr/>
         </p:nvSpPr>
@@ -6021,7 +6075,7 @@
       </p:sp>
       <p:sp>
         <p:nvSpPr>
-          <p:cNvPr id="1586707232" name="TextBox 7"/>
+          <p:cNvPr id="1056707616" name="TextBox 7"/>
           <p:cNvSpPr txBox="1"/>
           <p:nvPr/>
         </p:nvSpPr>
@@ -6071,7 +6125,7 @@
       </p:sp>
       <p:sp>
         <p:nvSpPr>
-          <p:cNvPr id="444200900" name="TextBox 8"/>
+          <p:cNvPr id="41285495" name="TextBox 8"/>
           <p:cNvSpPr txBox="1"/>
           <p:nvPr/>
         </p:nvSpPr>
@@ -6121,7 +6175,7 @@
       </p:sp>
       <p:sp>
         <p:nvSpPr>
-          <p:cNvPr id="1422525636" name="TextBox 9"/>
+          <p:cNvPr id="1316187093" name="TextBox 9"/>
           <p:cNvSpPr txBox="1"/>
           <p:nvPr/>
         </p:nvSpPr>
@@ -6171,7 +6225,7 @@
       </p:sp>
       <p:sp>
         <p:nvSpPr>
-          <p:cNvPr id="881151919" name="TextBox 10"/>
+          <p:cNvPr id="971794798" name="TextBox 10"/>
           <p:cNvSpPr txBox="1"/>
           <p:nvPr/>
         </p:nvSpPr>
@@ -6221,7 +6275,7 @@
       </p:sp>
       <p:sp>
         <p:nvSpPr>
-          <p:cNvPr id="1572081327" name="TextBox 11"/>
+          <p:cNvPr id="217255856" name="TextBox 11"/>
           <p:cNvSpPr txBox="1"/>
           <p:nvPr/>
         </p:nvSpPr>
@@ -6262,7 +6316,7 @@
       </p:sp>
       <p:sp>
         <p:nvSpPr>
-          <p:cNvPr id="683873759" name="TextBox 12"/>
+          <p:cNvPr id="1252963316" name="TextBox 12"/>
           <p:cNvSpPr txBox="1"/>
           <p:nvPr/>
         </p:nvSpPr>
@@ -6303,7 +6357,7 @@
       </p:sp>
       <p:sp>
         <p:nvSpPr>
-          <p:cNvPr id="898398785" name="TextBox 13"/>
+          <p:cNvPr id="848768397" name="TextBox 13"/>
           <p:cNvSpPr txBox="1"/>
           <p:nvPr/>
         </p:nvSpPr>
@@ -6344,7 +6398,7 @@
       </p:sp>
       <p:sp>
         <p:nvSpPr>
-          <p:cNvPr id="1676254538" name="TextBox 14"/>
+          <p:cNvPr id="784517382" name="TextBox 14"/>
           <p:cNvSpPr txBox="1"/>
           <p:nvPr/>
         </p:nvSpPr>
@@ -6385,7 +6439,7 @@
       </p:sp>
       <p:sp>
         <p:nvSpPr>
-          <p:cNvPr id="1661498731" name="TextBox 15"/>
+          <p:cNvPr id="519031776" name="TextBox 15"/>
           <p:cNvSpPr txBox="1"/>
           <p:nvPr/>
         </p:nvSpPr>
@@ -6417,6 +6471,32 @@
               </a:rPr>
               <a:t>Project Conclusion &amp; Key Achievements</a:t>
             </a:r>
+            <a:endParaRPr/>
+          </a:p>
+        </p:txBody>
+      </p:sp>
+      <p:sp>
+        <p:nvSpPr>
+          <p:cNvPr id="1005535138" name="Slide Number Placeholder 3"/>
+          <p:cNvSpPr>
+            <a:spLocks noGrp="1"/>
+          </p:cNvSpPr>
+          <p:nvPr>
+            <p:ph type="sldNum" sz="quarter" idx="12"/>
+          </p:nvPr>
+        </p:nvSpPr>
+        <p:spPr bwMode="auto"/>
+        <p:txBody>
+          <a:bodyPr/>
+          <a:lstStyle/>
+          <a:p>
+            <a:pPr>
+              <a:defRPr/>
+            </a:pPr>
+            <a:fld id="{BF36DF71-7588-4CE9-C05A-B510B5C05A7D}" type="slidenum">
+              <a:rPr lang="en-US"/>
+              <a:t>1</a:t>
+            </a:fld>
             <a:endParaRPr/>
           </a:p>
         </p:txBody>
@@ -6463,7 +6543,7 @@
       </p:grpSpPr>
       <p:pic>
         <p:nvPicPr>
-          <p:cNvPr id="235839607" name="Picture 1" descr="image.png"/>
+          <p:cNvPr id="1221922992" name="Picture 1" descr="image.png"/>
           <p:cNvPicPr>
             <a:picLocks noChangeAspect="1"/>
           </p:cNvPicPr>
@@ -6485,7 +6565,7 @@
       </p:pic>
       <p:pic>
         <p:nvPicPr>
-          <p:cNvPr id="2032919837" name="Picture 2" descr="image.png"/>
+          <p:cNvPr id="908533399" name="Picture 2" descr="image.png"/>
           <p:cNvPicPr>
             <a:picLocks noChangeAspect="1"/>
           </p:cNvPicPr>
@@ -6507,7 +6587,7 @@
       </p:pic>
       <p:pic>
         <p:nvPicPr>
-          <p:cNvPr id="1039019499" name="Picture 3" descr="image.png"/>
+          <p:cNvPr id="432700201" name="Picture 3" descr="image.png"/>
           <p:cNvPicPr>
             <a:picLocks noChangeAspect="1"/>
           </p:cNvPicPr>
@@ -6529,7 +6609,7 @@
       </p:pic>
       <p:pic>
         <p:nvPicPr>
-          <p:cNvPr id="40812543" name="Picture 4" descr="image.png"/>
+          <p:cNvPr id="1281179128" name="Picture 4" descr="image.png"/>
           <p:cNvPicPr>
             <a:picLocks noChangeAspect="1"/>
           </p:cNvPicPr>
@@ -6551,7 +6631,7 @@
       </p:pic>
       <p:pic>
         <p:nvPicPr>
-          <p:cNvPr id="1806051679" name="Picture 5" descr="image.png"/>
+          <p:cNvPr id="1285754197" name="Picture 5" descr="image.png"/>
           <p:cNvPicPr>
             <a:picLocks noChangeAspect="1"/>
           </p:cNvPicPr>
@@ -6573,7 +6653,7 @@
       </p:pic>
       <p:sp>
         <p:nvSpPr>
-          <p:cNvPr id="1725450963" name="TextBox 6"/>
+          <p:cNvPr id="2128508042" name="TextBox 6"/>
           <p:cNvSpPr txBox="1"/>
           <p:nvPr/>
         </p:nvSpPr>
@@ -6611,7 +6691,7 @@
       </p:sp>
       <p:sp>
         <p:nvSpPr>
-          <p:cNvPr id="703450906" name="TextBox 7"/>
+          <p:cNvPr id="2047148857" name="TextBox 7"/>
           <p:cNvSpPr txBox="1"/>
           <p:nvPr/>
         </p:nvSpPr>
@@ -6652,7 +6732,7 @@
       </p:sp>
       <p:sp>
         <p:nvSpPr>
-          <p:cNvPr id="1924271330" name="TextBox 8"/>
+          <p:cNvPr id="1260238916" name="TextBox 8"/>
           <p:cNvSpPr txBox="1"/>
           <p:nvPr/>
         </p:nvSpPr>
@@ -6690,7 +6770,7 @@
       </p:sp>
       <p:sp>
         <p:nvSpPr>
-          <p:cNvPr id="587402816" name="TextBox 9"/>
+          <p:cNvPr id="1464411238" name="TextBox 9"/>
           <p:cNvSpPr txBox="1"/>
           <p:nvPr/>
         </p:nvSpPr>
@@ -6731,7 +6811,7 @@
       </p:sp>
       <p:sp>
         <p:nvSpPr>
-          <p:cNvPr id="414590266" name="TextBox 10"/>
+          <p:cNvPr id="256411597" name="TextBox 10"/>
           <p:cNvSpPr txBox="1"/>
           <p:nvPr/>
         </p:nvSpPr>
@@ -6769,7 +6849,7 @@
       </p:sp>
       <p:sp>
         <p:nvSpPr>
-          <p:cNvPr id="2030002135" name="TextBox 11"/>
+          <p:cNvPr id="2077232552" name="TextBox 11"/>
           <p:cNvSpPr txBox="1"/>
           <p:nvPr/>
         </p:nvSpPr>
@@ -6810,7 +6890,7 @@
       </p:sp>
       <p:sp>
         <p:nvSpPr>
-          <p:cNvPr id="1097369572" name="TextBox 12"/>
+          <p:cNvPr id="1606766845" name="TextBox 12"/>
           <p:cNvSpPr txBox="1"/>
           <p:nvPr/>
         </p:nvSpPr>
@@ -6848,7 +6928,7 @@
       </p:sp>
       <p:sp>
         <p:nvSpPr>
-          <p:cNvPr id="809753727" name="TextBox 13"/>
+          <p:cNvPr id="548227061" name="TextBox 13"/>
           <p:cNvSpPr txBox="1"/>
           <p:nvPr/>
         </p:nvSpPr>
@@ -6889,7 +6969,7 @@
       </p:sp>
       <p:pic>
         <p:nvPicPr>
-          <p:cNvPr id="84695778" name="Picture 14" descr="image.png"/>
+          <p:cNvPr id="702898985" name="Picture 14" descr="image.png"/>
           <p:cNvPicPr>
             <a:picLocks noChangeAspect="1"/>
           </p:cNvPicPr>
@@ -6911,7 +6991,7 @@
       </p:pic>
       <p:pic>
         <p:nvPicPr>
-          <p:cNvPr id="1298332405" name="Picture 15" descr="image.png"/>
+          <p:cNvPr id="2091831127" name="Picture 15" descr="image.png"/>
           <p:cNvPicPr>
             <a:picLocks noChangeAspect="1"/>
           </p:cNvPicPr>
@@ -6933,7 +7013,7 @@
       </p:pic>
       <p:pic>
         <p:nvPicPr>
-          <p:cNvPr id="1352204829" name="Picture 16" descr="image.png"/>
+          <p:cNvPr id="885799208" name="Picture 16" descr="image.png"/>
           <p:cNvPicPr>
             <a:picLocks noChangeAspect="1"/>
           </p:cNvPicPr>
@@ -6953,6 +7033,32 @@
           </a:prstGeom>
         </p:spPr>
       </p:pic>
+      <p:sp>
+        <p:nvSpPr>
+          <p:cNvPr id="1970188328" name="Slide Number Placeholder 3"/>
+          <p:cNvSpPr>
+            <a:spLocks noGrp="1"/>
+          </p:cNvSpPr>
+          <p:nvPr>
+            <p:ph type="sldNum" sz="quarter" idx="12"/>
+          </p:nvPr>
+        </p:nvSpPr>
+        <p:spPr bwMode="auto"/>
+        <p:txBody>
+          <a:bodyPr/>
+          <a:lstStyle/>
+          <a:p>
+            <a:pPr>
+              <a:defRPr/>
+            </a:pPr>
+            <a:fld id="{42DEE464-256D-880B-73D3-E2D03B33C9B1}" type="slidenum">
+              <a:rPr lang="en-US"/>
+              <a:t>1</a:t>
+            </a:fld>
+            <a:endParaRPr/>
+          </a:p>
+        </p:txBody>
+      </p:sp>
     </p:spTree>
   </p:cSld>
   <p:clrMapOvr>
@@ -6995,7 +7101,7 @@
       </p:grpSpPr>
       <p:pic>
         <p:nvPicPr>
-          <p:cNvPr id="1981095677" name="Picture 1" descr="image.png"/>
+          <p:cNvPr id="371176673" name="Picture 1" descr="image.png"/>
           <p:cNvPicPr>
             <a:picLocks noChangeAspect="1"/>
           </p:cNvPicPr>
@@ -7017,7 +7123,7 @@
       </p:pic>
       <p:pic>
         <p:nvPicPr>
-          <p:cNvPr id="2088177749" name="Picture 2" descr="image.png"/>
+          <p:cNvPr id="1674517713" name="Picture 2" descr="image.png"/>
           <p:cNvPicPr>
             <a:picLocks noChangeAspect="1"/>
           </p:cNvPicPr>
@@ -7039,7 +7145,7 @@
       </p:pic>
       <p:pic>
         <p:nvPicPr>
-          <p:cNvPr id="1915274920" name="Picture 3" descr="image.png"/>
+          <p:cNvPr id="543835876" name="Picture 3" descr="image.png"/>
           <p:cNvPicPr>
             <a:picLocks noChangeAspect="1"/>
           </p:cNvPicPr>
@@ -7061,7 +7167,7 @@
       </p:pic>
       <p:pic>
         <p:nvPicPr>
-          <p:cNvPr id="230185150" name="Picture 4" descr="image.png"/>
+          <p:cNvPr id="1433600874" name="Picture 4" descr="image.png"/>
           <p:cNvPicPr>
             <a:picLocks noChangeAspect="1"/>
           </p:cNvPicPr>
@@ -7083,7 +7189,7 @@
       </p:pic>
       <p:sp>
         <p:nvSpPr>
-          <p:cNvPr id="338807612" name="TextBox 5"/>
+          <p:cNvPr id="600677653" name="TextBox 5"/>
           <p:cNvSpPr txBox="1"/>
           <p:nvPr/>
         </p:nvSpPr>
@@ -7121,7 +7227,7 @@
       </p:sp>
       <p:sp>
         <p:nvSpPr>
-          <p:cNvPr id="593789990" name="TextBox 6"/>
+          <p:cNvPr id="740783138" name="TextBox 6"/>
           <p:cNvSpPr txBox="1"/>
           <p:nvPr/>
         </p:nvSpPr>
@@ -7162,7 +7268,7 @@
       </p:sp>
       <p:sp>
         <p:nvSpPr>
-          <p:cNvPr id="1631071564" name="TextBox 7"/>
+          <p:cNvPr id="1522890303" name="TextBox 7"/>
           <p:cNvSpPr txBox="1"/>
           <p:nvPr/>
         </p:nvSpPr>
@@ -7203,7 +7309,7 @@
       </p:sp>
       <p:sp>
         <p:nvSpPr>
-          <p:cNvPr id="808054163" name="TextBox 8"/>
+          <p:cNvPr id="1294288651" name="TextBox 8"/>
           <p:cNvSpPr txBox="1"/>
           <p:nvPr/>
         </p:nvSpPr>
@@ -7241,7 +7347,7 @@
       </p:sp>
       <p:sp>
         <p:nvSpPr>
-          <p:cNvPr id="1989327975" name="TextBox 9"/>
+          <p:cNvPr id="1959069594" name="TextBox 9"/>
           <p:cNvSpPr txBox="1"/>
           <p:nvPr/>
         </p:nvSpPr>
@@ -7282,7 +7388,7 @@
       </p:sp>
       <p:sp>
         <p:nvSpPr>
-          <p:cNvPr id="164808796" name="TextBox 10"/>
+          <p:cNvPr id="467857900" name="TextBox 10"/>
           <p:cNvSpPr txBox="1"/>
           <p:nvPr/>
         </p:nvSpPr>
@@ -7323,7 +7429,7 @@
       </p:sp>
       <p:pic>
         <p:nvPicPr>
-          <p:cNvPr id="2038348395" name="Picture 11" descr="image.png"/>
+          <p:cNvPr id="492018703" name="Picture 11" descr="image.png"/>
           <p:cNvPicPr>
             <a:picLocks noChangeAspect="1"/>
           </p:cNvPicPr>
@@ -7345,7 +7451,7 @@
       </p:pic>
       <p:pic>
         <p:nvPicPr>
-          <p:cNvPr id="1880994785" name="Picture 12" descr="image.png"/>
+          <p:cNvPr id="1005546206" name="Picture 12" descr="image.png"/>
           <p:cNvPicPr>
             <a:picLocks noChangeAspect="1"/>
           </p:cNvPicPr>
@@ -7367,7 +7473,7 @@
       </p:pic>
       <p:sp>
         <p:nvSpPr>
-          <p:cNvPr id="584982824" name="TextBox 13"/>
+          <p:cNvPr id="1793886883" name="TextBox 13"/>
           <p:cNvSpPr txBox="1"/>
           <p:nvPr/>
         </p:nvSpPr>
@@ -7399,6 +7505,32 @@
               </a:rPr>
               <a:t>Problem &amp; Motivation</a:t>
             </a:r>
+            <a:endParaRPr/>
+          </a:p>
+        </p:txBody>
+      </p:sp>
+      <p:sp>
+        <p:nvSpPr>
+          <p:cNvPr id="2105783321" name="Slide Number Placeholder 3"/>
+          <p:cNvSpPr>
+            <a:spLocks noGrp="1"/>
+          </p:cNvSpPr>
+          <p:nvPr>
+            <p:ph type="sldNum" sz="quarter" idx="12"/>
+          </p:nvPr>
+        </p:nvSpPr>
+        <p:spPr bwMode="auto"/>
+        <p:txBody>
+          <a:bodyPr/>
+          <a:lstStyle/>
+          <a:p>
+            <a:pPr>
+              <a:defRPr/>
+            </a:pPr>
+            <a:fld id="{E9225F5D-5B27-880F-5AC0-9E1E505A86E7}" type="slidenum">
+              <a:rPr lang="en-US"/>
+              <a:t>1</a:t>
+            </a:fld>
             <a:endParaRPr/>
           </a:p>
         </p:txBody>
@@ -7445,7 +7577,7 @@
       </p:grpSpPr>
       <p:pic>
         <p:nvPicPr>
-          <p:cNvPr id="1133705927" name="Picture 3" descr="image.png"/>
+          <p:cNvPr id="699043133" name="Picture 3" descr="image.png"/>
           <p:cNvPicPr>
             <a:picLocks noChangeAspect="1"/>
           </p:cNvPicPr>
@@ -7467,7 +7599,7 @@
       </p:pic>
       <p:sp>
         <p:nvSpPr>
-          <p:cNvPr id="589347932" name="TextBox 4"/>
+          <p:cNvPr id="177817959" name="TextBox 4"/>
           <p:cNvSpPr txBox="1"/>
           <p:nvPr/>
         </p:nvSpPr>
@@ -7505,7 +7637,7 @@
       </p:sp>
       <p:sp>
         <p:nvSpPr>
-          <p:cNvPr id="2021033819" name="TextBox 5"/>
+          <p:cNvPr id="630833313" name="TextBox 5"/>
           <p:cNvSpPr txBox="1"/>
           <p:nvPr/>
         </p:nvSpPr>
@@ -7555,7 +7687,7 @@
       </p:sp>
       <p:sp>
         <p:nvSpPr>
-          <p:cNvPr id="850165635" name="TextBox 6"/>
+          <p:cNvPr id="927659545" name="TextBox 6"/>
           <p:cNvSpPr txBox="1"/>
           <p:nvPr/>
         </p:nvSpPr>
@@ -7605,7 +7737,7 @@
       </p:sp>
       <p:sp>
         <p:nvSpPr>
-          <p:cNvPr id="1794322419" name="TextBox 7"/>
+          <p:cNvPr id="202853067" name="TextBox 7"/>
           <p:cNvSpPr txBox="1"/>
           <p:nvPr/>
         </p:nvSpPr>
@@ -7655,7 +7787,7 @@
       </p:sp>
       <p:sp>
         <p:nvSpPr>
-          <p:cNvPr id="67136583" name="TextBox 8"/>
+          <p:cNvPr id="92425593" name="TextBox 8"/>
           <p:cNvSpPr txBox="1"/>
           <p:nvPr/>
         </p:nvSpPr>
@@ -7705,7 +7837,7 @@
       </p:sp>
       <p:sp>
         <p:nvSpPr>
-          <p:cNvPr id="1083338212" name="TextBox 9"/>
+          <p:cNvPr id="422334076" name="TextBox 9"/>
           <p:cNvSpPr txBox="1"/>
           <p:nvPr/>
         </p:nvSpPr>
@@ -7755,7 +7887,7 @@
       </p:sp>
       <p:sp>
         <p:nvSpPr>
-          <p:cNvPr id="1395219140" name="TextBox 11"/>
+          <p:cNvPr id="508356002" name="TextBox 11"/>
           <p:cNvSpPr txBox="1"/>
           <p:nvPr/>
         </p:nvSpPr>
@@ -7796,7 +7928,7 @@
       </p:sp>
       <p:sp>
         <p:nvSpPr>
-          <p:cNvPr id="733397923" name="TextBox 12"/>
+          <p:cNvPr id="1604438873" name="TextBox 12"/>
           <p:cNvSpPr txBox="1"/>
           <p:nvPr/>
         </p:nvSpPr>
@@ -7837,7 +7969,7 @@
       </p:sp>
       <p:sp>
         <p:nvSpPr>
-          <p:cNvPr id="1039187574" name="TextBox 13"/>
+          <p:cNvPr id="1662159693" name="TextBox 13"/>
           <p:cNvSpPr txBox="1"/>
           <p:nvPr/>
         </p:nvSpPr>
@@ -7878,7 +8010,7 @@
       </p:sp>
       <p:sp>
         <p:nvSpPr>
-          <p:cNvPr id="355707088" name="TextBox 14"/>
+          <p:cNvPr id="1007473949" name="TextBox 14"/>
           <p:cNvSpPr txBox="1"/>
           <p:nvPr/>
         </p:nvSpPr>
@@ -7919,7 +8051,7 @@
       </p:sp>
       <p:sp>
         <p:nvSpPr>
-          <p:cNvPr id="256828818" name="TextBox 15"/>
+          <p:cNvPr id="1259652779" name="TextBox 15"/>
           <p:cNvSpPr txBox="1"/>
           <p:nvPr/>
         </p:nvSpPr>
@@ -7960,7 +8092,7 @@
       </p:sp>
       <p:sp>
         <p:nvSpPr>
-          <p:cNvPr id="1910099328" name="TextBox 16"/>
+          <p:cNvPr id="1087048749" name="TextBox 16"/>
           <p:cNvSpPr txBox="1"/>
           <p:nvPr/>
         </p:nvSpPr>
@@ -7998,7 +8130,7 @@
       </p:sp>
       <p:pic>
         <p:nvPicPr>
-          <p:cNvPr id="286960079" name="Picture 1"/>
+          <p:cNvPr id="817692892" name="Picture 1"/>
           <p:cNvPicPr>
             <a:picLocks noChangeAspect="1"/>
           </p:cNvPicPr>
@@ -8018,6 +8150,32 @@
           </a:prstGeom>
         </p:spPr>
       </p:pic>
+      <p:sp>
+        <p:nvSpPr>
+          <p:cNvPr id="1433306400" name="Slide Number Placeholder 3"/>
+          <p:cNvSpPr>
+            <a:spLocks noGrp="1"/>
+          </p:cNvSpPr>
+          <p:nvPr>
+            <p:ph type="sldNum" sz="quarter" idx="12"/>
+          </p:nvPr>
+        </p:nvSpPr>
+        <p:spPr bwMode="auto"/>
+        <p:txBody>
+          <a:bodyPr/>
+          <a:lstStyle/>
+          <a:p>
+            <a:pPr>
+              <a:defRPr/>
+            </a:pPr>
+            <a:fld id="{B995618B-313E-221D-E171-2F456705C20C}" type="slidenum">
+              <a:rPr lang="en-US"/>
+              <a:t>1</a:t>
+            </a:fld>
+            <a:endParaRPr/>
+          </a:p>
+        </p:txBody>
+      </p:sp>
     </p:spTree>
   </p:cSld>
   <p:clrMapOvr>
@@ -8060,7 +8218,7 @@
       </p:grpSpPr>
       <p:pic>
         <p:nvPicPr>
-          <p:cNvPr id="946381501" name="Picture 1" descr="image.png"/>
+          <p:cNvPr id="102722274" name="Picture 1" descr="image.png"/>
           <p:cNvPicPr>
             <a:picLocks noChangeAspect="1"/>
           </p:cNvPicPr>
@@ -8082,7 +8240,7 @@
       </p:pic>
       <p:pic>
         <p:nvPicPr>
-          <p:cNvPr id="1688282363" name="Picture 2" descr="image.png"/>
+          <p:cNvPr id="1516676645" name="Picture 2" descr="image.png"/>
           <p:cNvPicPr>
             <a:picLocks noChangeAspect="1"/>
           </p:cNvPicPr>
@@ -8104,7 +8262,7 @@
       </p:pic>
       <p:sp>
         <p:nvSpPr>
-          <p:cNvPr id="987020932" name="TextBox 3"/>
+          <p:cNvPr id="653969722" name="TextBox 3"/>
           <p:cNvSpPr txBox="1"/>
           <p:nvPr/>
         </p:nvSpPr>
@@ -8142,7 +8300,7 @@
       </p:sp>
       <p:pic>
         <p:nvPicPr>
-          <p:cNvPr id="1441846880" name="Picture 5" descr="image.png"/>
+          <p:cNvPr id="479699082" name="Picture 5" descr="image.png"/>
           <p:cNvPicPr>
             <a:picLocks noChangeAspect="1"/>
           </p:cNvPicPr>
@@ -8164,7 +8322,7 @@
       </p:pic>
       <p:sp>
         <p:nvSpPr>
-          <p:cNvPr id="620711936" name="TextBox 6"/>
+          <p:cNvPr id="100623584" name="TextBox 6"/>
           <p:cNvSpPr txBox="1"/>
           <p:nvPr/>
         </p:nvSpPr>
@@ -8202,7 +8360,7 @@
       </p:sp>
       <p:sp>
         <p:nvSpPr>
-          <p:cNvPr id="245801908" name="TextBox 7"/>
+          <p:cNvPr id="99739963" name="TextBox 7"/>
           <p:cNvSpPr txBox="1"/>
           <p:nvPr/>
         </p:nvSpPr>
@@ -8252,7 +8410,7 @@
       </p:sp>
       <p:sp>
         <p:nvSpPr>
-          <p:cNvPr id="99043920" name="TextBox 8"/>
+          <p:cNvPr id="554101388" name="TextBox 8"/>
           <p:cNvSpPr txBox="1"/>
           <p:nvPr/>
         </p:nvSpPr>
@@ -8302,7 +8460,7 @@
       </p:sp>
       <p:sp>
         <p:nvSpPr>
-          <p:cNvPr id="1398418412" name="TextBox 9"/>
+          <p:cNvPr id="974046946" name="TextBox 9"/>
           <p:cNvSpPr txBox="1"/>
           <p:nvPr/>
         </p:nvSpPr>
@@ -8352,7 +8510,7 @@
       </p:sp>
       <p:pic>
         <p:nvPicPr>
-          <p:cNvPr id="1317115061" name="Picture 10"/>
+          <p:cNvPr id="1575956821" name="Picture 10"/>
           <p:cNvPicPr>
             <a:picLocks noChangeAspect="1"/>
           </p:cNvPicPr>
@@ -8372,6 +8530,32 @@
           </a:prstGeom>
         </p:spPr>
       </p:pic>
+      <p:sp>
+        <p:nvSpPr>
+          <p:cNvPr id="58326714" name="Slide Number Placeholder 3"/>
+          <p:cNvSpPr>
+            <a:spLocks noGrp="1"/>
+          </p:cNvSpPr>
+          <p:nvPr>
+            <p:ph type="sldNum" sz="quarter" idx="12"/>
+          </p:nvPr>
+        </p:nvSpPr>
+        <p:spPr bwMode="auto"/>
+        <p:txBody>
+          <a:bodyPr/>
+          <a:lstStyle/>
+          <a:p>
+            <a:pPr>
+              <a:defRPr/>
+            </a:pPr>
+            <a:fld id="{C4EAB0EC-4E2C-C665-4A08-69E4B878E3EF}" type="slidenum">
+              <a:rPr lang="en-US"/>
+              <a:t>1</a:t>
+            </a:fld>
+            <a:endParaRPr/>
+          </a:p>
+        </p:txBody>
+      </p:sp>
     </p:spTree>
   </p:cSld>
   <p:clrMapOvr>
@@ -8414,7 +8598,7 @@
       </p:grpSpPr>
       <p:pic>
         <p:nvPicPr>
-          <p:cNvPr id="321456488" name="Picture 1" descr="image.png"/>
+          <p:cNvPr id="1440079318" name="Picture 1" descr="image.png"/>
           <p:cNvPicPr>
             <a:picLocks noChangeAspect="1"/>
           </p:cNvPicPr>
@@ -8436,7 +8620,7 @@
       </p:pic>
       <p:pic>
         <p:nvPicPr>
-          <p:cNvPr id="1885078936" name="Picture 2" descr="image.png"/>
+          <p:cNvPr id="1883569830" name="Picture 2" descr="image.png"/>
           <p:cNvPicPr>
             <a:picLocks noChangeAspect="1"/>
           </p:cNvPicPr>
@@ -8458,7 +8642,7 @@
       </p:pic>
       <p:pic>
         <p:nvPicPr>
-          <p:cNvPr id="1241447217" name="Picture 3" descr="image.png"/>
+          <p:cNvPr id="1250317366" name="Picture 3" descr="image.png"/>
           <p:cNvPicPr>
             <a:picLocks noChangeAspect="1"/>
           </p:cNvPicPr>
@@ -8480,7 +8664,7 @@
       </p:pic>
       <p:pic>
         <p:nvPicPr>
-          <p:cNvPr id="1006254649" name="Picture 4" descr="image.png"/>
+          <p:cNvPr id="130829869" name="Picture 4" descr="image.png"/>
           <p:cNvPicPr>
             <a:picLocks noChangeAspect="1"/>
           </p:cNvPicPr>
@@ -8502,7 +8686,7 @@
       </p:pic>
       <p:pic>
         <p:nvPicPr>
-          <p:cNvPr id="667090869" name="Picture 5" descr="image.png"/>
+          <p:cNvPr id="1090598638" name="Picture 5" descr="image.png"/>
           <p:cNvPicPr>
             <a:picLocks noChangeAspect="1"/>
           </p:cNvPicPr>
@@ -8524,7 +8708,7 @@
       </p:pic>
       <p:pic>
         <p:nvPicPr>
-          <p:cNvPr id="1746007361" name="Picture 6" descr="image.png"/>
+          <p:cNvPr id="1289460438" name="Picture 6" descr="image.png"/>
           <p:cNvPicPr>
             <a:picLocks noChangeAspect="1"/>
           </p:cNvPicPr>
@@ -8546,7 +8730,7 @@
       </p:pic>
       <p:sp>
         <p:nvSpPr>
-          <p:cNvPr id="934768667" name="TextBox 7"/>
+          <p:cNvPr id="1356150130" name="TextBox 7"/>
           <p:cNvSpPr txBox="1"/>
           <p:nvPr/>
         </p:nvSpPr>
@@ -8584,7 +8768,7 @@
       </p:sp>
       <p:sp>
         <p:nvSpPr>
-          <p:cNvPr id="1968539732" name="TextBox 8"/>
+          <p:cNvPr id="103237877" name="TextBox 8"/>
           <p:cNvSpPr txBox="1"/>
           <p:nvPr/>
         </p:nvSpPr>
@@ -8625,7 +8809,7 @@
       </p:sp>
       <p:pic>
         <p:nvPicPr>
-          <p:cNvPr id="1626630703" name="Picture 9" descr="image.png"/>
+          <p:cNvPr id="2085903286" name="Picture 9" descr="image.png"/>
           <p:cNvPicPr>
             <a:picLocks noChangeAspect="1"/>
           </p:cNvPicPr>
@@ -8647,7 +8831,7 @@
       </p:pic>
       <p:sp>
         <p:nvSpPr>
-          <p:cNvPr id="1938240382" name="TextBox 10"/>
+          <p:cNvPr id="1389990986" name="TextBox 10"/>
           <p:cNvSpPr txBox="1"/>
           <p:nvPr/>
         </p:nvSpPr>
@@ -8685,7 +8869,7 @@
       </p:sp>
       <p:sp>
         <p:nvSpPr>
-          <p:cNvPr id="1631653223" name="TextBox 11"/>
+          <p:cNvPr id="1782405791" name="TextBox 11"/>
           <p:cNvSpPr txBox="1"/>
           <p:nvPr/>
         </p:nvSpPr>
@@ -8726,7 +8910,7 @@
       </p:sp>
       <p:pic>
         <p:nvPicPr>
-          <p:cNvPr id="911843892" name="Picture 12" descr="image.png"/>
+          <p:cNvPr id="924804885" name="Picture 12" descr="image.png"/>
           <p:cNvPicPr>
             <a:picLocks noChangeAspect="1"/>
           </p:cNvPicPr>
@@ -8748,7 +8932,7 @@
       </p:pic>
       <p:sp>
         <p:nvSpPr>
-          <p:cNvPr id="1700583354" name="TextBox 13"/>
+          <p:cNvPr id="1475921411" name="TextBox 13"/>
           <p:cNvSpPr txBox="1"/>
           <p:nvPr/>
         </p:nvSpPr>
@@ -8786,7 +8970,7 @@
       </p:sp>
       <p:sp>
         <p:nvSpPr>
-          <p:cNvPr id="1861697034" name="TextBox 14"/>
+          <p:cNvPr id="1015405755" name="TextBox 14"/>
           <p:cNvSpPr txBox="1"/>
           <p:nvPr/>
         </p:nvSpPr>
@@ -8827,7 +9011,7 @@
       </p:sp>
       <p:pic>
         <p:nvPicPr>
-          <p:cNvPr id="1121920136" name="Picture 15" descr="image.png"/>
+          <p:cNvPr id="1446409707" name="Picture 15" descr="image.png"/>
           <p:cNvPicPr>
             <a:picLocks noChangeAspect="1"/>
           </p:cNvPicPr>
@@ -8849,7 +9033,7 @@
       </p:pic>
       <p:pic>
         <p:nvPicPr>
-          <p:cNvPr id="1771915202" name="Picture 16" descr="image.png"/>
+          <p:cNvPr id="1757924082" name="Picture 16" descr="image.png"/>
           <p:cNvPicPr>
             <a:picLocks noChangeAspect="1"/>
           </p:cNvPicPr>
@@ -8871,7 +9055,7 @@
       </p:pic>
       <p:pic>
         <p:nvPicPr>
-          <p:cNvPr id="1325625833" name="Picture 17" descr="image.png"/>
+          <p:cNvPr id="654990928" name="Picture 17" descr="image.png"/>
           <p:cNvPicPr>
             <a:picLocks noChangeAspect="1"/>
           </p:cNvPicPr>
@@ -8893,7 +9077,7 @@
       </p:pic>
       <p:sp>
         <p:nvSpPr>
-          <p:cNvPr id="881470299" name="TextBox 18"/>
+          <p:cNvPr id="1311683757" name="TextBox 18"/>
           <p:cNvSpPr txBox="1"/>
           <p:nvPr/>
         </p:nvSpPr>
@@ -8925,6 +9109,32 @@
               </a:rPr>
               <a:t>Core C++ OOP Principles</a:t>
             </a:r>
+            <a:endParaRPr/>
+          </a:p>
+        </p:txBody>
+      </p:sp>
+      <p:sp>
+        <p:nvSpPr>
+          <p:cNvPr id="11659214" name="Slide Number Placeholder 3"/>
+          <p:cNvSpPr>
+            <a:spLocks noGrp="1"/>
+          </p:cNvSpPr>
+          <p:nvPr>
+            <p:ph type="sldNum" sz="quarter" idx="12"/>
+          </p:nvPr>
+        </p:nvSpPr>
+        <p:spPr bwMode="auto"/>
+        <p:txBody>
+          <a:bodyPr/>
+          <a:lstStyle/>
+          <a:p>
+            <a:pPr>
+              <a:defRPr/>
+            </a:pPr>
+            <a:fld id="{50079615-9416-C53F-21F2-A1C64CE9F496}" type="slidenum">
+              <a:rPr lang="en-US"/>
+              <a:t>1</a:t>
+            </a:fld>
             <a:endParaRPr/>
           </a:p>
         </p:txBody>
@@ -8971,7 +9181,7 @@
       </p:grpSpPr>
       <p:pic>
         <p:nvPicPr>
-          <p:cNvPr id="863641517" name="Picture 1" descr="image.png"/>
+          <p:cNvPr id="1129052936" name="Picture 1" descr="image.png"/>
           <p:cNvPicPr>
             <a:picLocks noChangeAspect="1"/>
           </p:cNvPicPr>
@@ -8993,7 +9203,7 @@
       </p:pic>
       <p:pic>
         <p:nvPicPr>
-          <p:cNvPr id="184642619" name="Picture 2" descr="image.png"/>
+          <p:cNvPr id="146546050" name="Picture 2" descr="image.png"/>
           <p:cNvPicPr>
             <a:picLocks noChangeAspect="1"/>
           </p:cNvPicPr>
@@ -9015,7 +9225,7 @@
       </p:pic>
       <p:pic>
         <p:nvPicPr>
-          <p:cNvPr id="2052955158" name="Picture 3" descr="image.png"/>
+          <p:cNvPr id="1599725274" name="Picture 3" descr="image.png"/>
           <p:cNvPicPr>
             <a:picLocks noChangeAspect="1"/>
           </p:cNvPicPr>
@@ -9037,7 +9247,7 @@
       </p:pic>
       <p:pic>
         <p:nvPicPr>
-          <p:cNvPr id="764572255" name="Picture 4" descr="image.png"/>
+          <p:cNvPr id="1086614109" name="Picture 4" descr="image.png"/>
           <p:cNvPicPr>
             <a:picLocks noChangeAspect="1"/>
           </p:cNvPicPr>
@@ -9059,7 +9269,7 @@
       </p:pic>
       <p:sp>
         <p:nvSpPr>
-          <p:cNvPr id="2107308419" name="TextBox 5"/>
+          <p:cNvPr id="1753584906" name="TextBox 5"/>
           <p:cNvSpPr txBox="1"/>
           <p:nvPr/>
         </p:nvSpPr>
@@ -9097,7 +9307,7 @@
       </p:sp>
       <p:sp>
         <p:nvSpPr>
-          <p:cNvPr id="513302448" name="TextBox 6"/>
+          <p:cNvPr id="803615158" name="TextBox 6"/>
           <p:cNvSpPr txBox="1"/>
           <p:nvPr/>
         </p:nvSpPr>
@@ -9147,7 +9357,7 @@
       </p:sp>
       <p:sp>
         <p:nvSpPr>
-          <p:cNvPr id="1047373570" name="TextBox 7"/>
+          <p:cNvPr id="1565026601" name="TextBox 7"/>
           <p:cNvSpPr txBox="1"/>
           <p:nvPr/>
         </p:nvSpPr>
@@ -9197,7 +9407,7 @@
       </p:sp>
       <p:sp>
         <p:nvSpPr>
-          <p:cNvPr id="1177388764" name="TextBox 8"/>
+          <p:cNvPr id="2101759372" name="TextBox 8"/>
           <p:cNvSpPr txBox="1"/>
           <p:nvPr/>
         </p:nvSpPr>
@@ -9235,7 +9445,7 @@
       </p:sp>
       <p:sp>
         <p:nvSpPr>
-          <p:cNvPr id="252606087" name="TextBox 9"/>
+          <p:cNvPr id="2110884421" name="TextBox 9"/>
           <p:cNvSpPr txBox="1"/>
           <p:nvPr/>
         </p:nvSpPr>
@@ -9285,7 +9495,7 @@
       </p:sp>
       <p:sp>
         <p:nvSpPr>
-          <p:cNvPr id="2131776187" name="TextBox 10"/>
+          <p:cNvPr id="518893203" name="TextBox 10"/>
           <p:cNvSpPr txBox="1"/>
           <p:nvPr/>
         </p:nvSpPr>
@@ -9335,7 +9545,7 @@
       </p:sp>
       <p:pic>
         <p:nvPicPr>
-          <p:cNvPr id="762693997" name="Picture 11" descr="image.png"/>
+          <p:cNvPr id="1890256440" name="Picture 11" descr="image.png"/>
           <p:cNvPicPr>
             <a:picLocks noChangeAspect="1"/>
           </p:cNvPicPr>
@@ -9357,7 +9567,7 @@
       </p:pic>
       <p:sp>
         <p:nvSpPr>
-          <p:cNvPr id="1533214389" name="TextBox 12"/>
+          <p:cNvPr id="1126622871" name="TextBox 12"/>
           <p:cNvSpPr txBox="1"/>
           <p:nvPr/>
         </p:nvSpPr>
@@ -9389,6 +9599,32 @@
               </a:rPr>
               <a:t>Advanced C++ Features</a:t>
             </a:r>
+            <a:endParaRPr/>
+          </a:p>
+        </p:txBody>
+      </p:sp>
+      <p:sp>
+        <p:nvSpPr>
+          <p:cNvPr id="1581278072" name="Slide Number Placeholder 3"/>
+          <p:cNvSpPr>
+            <a:spLocks noGrp="1"/>
+          </p:cNvSpPr>
+          <p:nvPr>
+            <p:ph type="sldNum" sz="quarter" idx="12"/>
+          </p:nvPr>
+        </p:nvSpPr>
+        <p:spPr bwMode="auto"/>
+        <p:txBody>
+          <a:bodyPr/>
+          <a:lstStyle/>
+          <a:p>
+            <a:pPr>
+              <a:defRPr/>
+            </a:pPr>
+            <a:fld id="{9C508C9C-FEBA-A0B5-4511-10AB2F527A3A}" type="slidenum">
+              <a:rPr lang="en-US"/>
+              <a:t>1</a:t>
+            </a:fld>
             <a:endParaRPr/>
           </a:p>
         </p:txBody>
@@ -9435,7 +9671,7 @@
       </p:grpSpPr>
       <p:pic>
         <p:nvPicPr>
-          <p:cNvPr id="995838708" name="Picture 1" descr="image.png"/>
+          <p:cNvPr id="1596828553" name="Picture 1" descr="image.png"/>
           <p:cNvPicPr>
             <a:picLocks noChangeAspect="1"/>
           </p:cNvPicPr>
@@ -9457,7 +9693,7 @@
       </p:pic>
       <p:pic>
         <p:nvPicPr>
-          <p:cNvPr id="861450831" name="Picture 3" descr="image.png"/>
+          <p:cNvPr id="1704028787" name="Picture 3" descr="image.png"/>
           <p:cNvPicPr>
             <a:picLocks noChangeAspect="1"/>
           </p:cNvPicPr>
@@ -9479,7 +9715,7 @@
       </p:pic>
       <p:sp>
         <p:nvSpPr>
-          <p:cNvPr id="612692331" name="Rounded Rectangle 5"/>
+          <p:cNvPr id="1882129341" name="Rounded Rectangle 5"/>
           <p:cNvSpPr/>
           <p:nvPr/>
         </p:nvSpPr>
@@ -9530,7 +9766,7 @@
       </p:sp>
       <p:sp>
         <p:nvSpPr>
-          <p:cNvPr id="1856453069" name="TextBox 6"/>
+          <p:cNvPr id="923962975" name="TextBox 6"/>
           <p:cNvSpPr txBox="1"/>
           <p:nvPr/>
         </p:nvSpPr>
@@ -9580,7 +9816,7 @@
       </p:sp>
       <p:sp>
         <p:nvSpPr>
-          <p:cNvPr id="87081033" name="Rounded Rectangle 7"/>
+          <p:cNvPr id="1972599384" name="Rounded Rectangle 7"/>
           <p:cNvSpPr/>
           <p:nvPr/>
         </p:nvSpPr>
@@ -9631,7 +9867,7 @@
       </p:sp>
       <p:sp>
         <p:nvSpPr>
-          <p:cNvPr id="1420467850" name="TextBox 8"/>
+          <p:cNvPr id="458875291" name="TextBox 8"/>
           <p:cNvSpPr txBox="1"/>
           <p:nvPr/>
         </p:nvSpPr>
@@ -9681,7 +9917,7 @@
       </p:sp>
       <p:sp>
         <p:nvSpPr>
-          <p:cNvPr id="279786159" name="Rounded Rectangle 9"/>
+          <p:cNvPr id="2104961260" name="Rounded Rectangle 9"/>
           <p:cNvSpPr/>
           <p:nvPr/>
         </p:nvSpPr>
@@ -9732,7 +9968,7 @@
       </p:sp>
       <p:sp>
         <p:nvSpPr>
-          <p:cNvPr id="606853275" name="TextBox 10"/>
+          <p:cNvPr id="1789470588" name="TextBox 10"/>
           <p:cNvSpPr txBox="1"/>
           <p:nvPr/>
         </p:nvSpPr>
@@ -9782,7 +10018,7 @@
       </p:sp>
       <p:sp>
         <p:nvSpPr>
-          <p:cNvPr id="686607306" name="TextBox 11"/>
+          <p:cNvPr id="748819557" name="TextBox 11"/>
           <p:cNvSpPr txBox="1"/>
           <p:nvPr/>
         </p:nvSpPr>
@@ -9823,7 +10059,7 @@
       </p:sp>
       <p:sp>
         <p:nvSpPr>
-          <p:cNvPr id="599781197" name="Rectangle 12"/>
+          <p:cNvPr id="1220369675" name="Rectangle 12"/>
           <p:cNvSpPr/>
           <p:nvPr/>
         </p:nvSpPr>
@@ -9870,7 +10106,7 @@
       </p:sp>
       <p:sp>
         <p:nvSpPr>
-          <p:cNvPr id="569041201" name="TextBox 13"/>
+          <p:cNvPr id="1838428394" name="TextBox 13"/>
           <p:cNvSpPr txBox="1"/>
           <p:nvPr/>
         </p:nvSpPr>
@@ -9911,7 +10147,7 @@
       </p:sp>
       <p:sp>
         <p:nvSpPr>
-          <p:cNvPr id="94691369" name="Rectangle 14"/>
+          <p:cNvPr id="1001258791" name="Rectangle 14"/>
           <p:cNvSpPr/>
           <p:nvPr/>
         </p:nvSpPr>
@@ -9958,7 +10194,7 @@
       </p:sp>
       <p:sp>
         <p:nvSpPr>
-          <p:cNvPr id="1872306954" name="TextBox 15"/>
+          <p:cNvPr id="928275890" name="TextBox 15"/>
           <p:cNvSpPr txBox="1"/>
           <p:nvPr/>
         </p:nvSpPr>
@@ -9999,7 +10235,7 @@
       </p:sp>
       <p:sp>
         <p:nvSpPr>
-          <p:cNvPr id="1868642185" name="Rectangle 16"/>
+          <p:cNvPr id="2102528987" name="Rectangle 16"/>
           <p:cNvSpPr/>
           <p:nvPr/>
         </p:nvSpPr>
@@ -10046,7 +10282,7 @@
       </p:sp>
       <p:pic>
         <p:nvPicPr>
-          <p:cNvPr id="1666151151" name="Picture 17" descr="image.png"/>
+          <p:cNvPr id="233218856" name="Picture 17" descr="image.png"/>
           <p:cNvPicPr>
             <a:picLocks noChangeAspect="1"/>
           </p:cNvPicPr>
@@ -10068,7 +10304,7 @@
       </p:pic>
       <p:pic>
         <p:nvPicPr>
-          <p:cNvPr id="374512409" name="Picture 18" descr="image.png"/>
+          <p:cNvPr id="1304986406" name="Picture 18" descr="image.png"/>
           <p:cNvPicPr>
             <a:picLocks noChangeAspect="1"/>
           </p:cNvPicPr>
@@ -10090,7 +10326,7 @@
       </p:pic>
       <p:pic>
         <p:nvPicPr>
-          <p:cNvPr id="2146565215" name="Picture 19" descr="image.png"/>
+          <p:cNvPr id="738710474" name="Picture 19" descr="image.png"/>
           <p:cNvPicPr>
             <a:picLocks noChangeAspect="1"/>
           </p:cNvPicPr>
@@ -10112,7 +10348,7 @@
       </p:pic>
       <p:sp>
         <p:nvSpPr>
-          <p:cNvPr id="245892119" name="TextBox 20"/>
+          <p:cNvPr id="1669212073" name="TextBox 20"/>
           <p:cNvSpPr txBox="1"/>
           <p:nvPr/>
         </p:nvSpPr>
@@ -10150,7 +10386,7 @@
       </p:sp>
       <p:pic>
         <p:nvPicPr>
-          <p:cNvPr id="932346223" name="Picture 21"/>
+          <p:cNvPr id="1565027873" name="Picture 21"/>
           <p:cNvPicPr>
             <a:picLocks noChangeAspect="1"/>
           </p:cNvPicPr>
@@ -10170,6 +10406,32 @@
           </a:prstGeom>
         </p:spPr>
       </p:pic>
+      <p:sp>
+        <p:nvSpPr>
+          <p:cNvPr id="124326992" name="Slide Number Placeholder 3"/>
+          <p:cNvSpPr>
+            <a:spLocks noGrp="1"/>
+          </p:cNvSpPr>
+          <p:nvPr>
+            <p:ph type="sldNum" sz="quarter" idx="12"/>
+          </p:nvPr>
+        </p:nvSpPr>
+        <p:spPr bwMode="auto"/>
+        <p:txBody>
+          <a:bodyPr/>
+          <a:lstStyle/>
+          <a:p>
+            <a:pPr>
+              <a:defRPr/>
+            </a:pPr>
+            <a:fld id="{E1C0D89C-CB30-C96D-6842-0D5ED4A51595}" type="slidenum">
+              <a:rPr lang="en-US"/>
+              <a:t>1</a:t>
+            </a:fld>
+            <a:endParaRPr/>
+          </a:p>
+        </p:txBody>
+      </p:sp>
     </p:spTree>
   </p:cSld>
   <p:clrMapOvr>
@@ -10212,7 +10474,7 @@
       </p:grpSpPr>
       <p:pic>
         <p:nvPicPr>
-          <p:cNvPr id="899022073" name="Picture 1" descr="image.png"/>
+          <p:cNvPr id="403031255" name="Picture 1" descr="image.png"/>
           <p:cNvPicPr>
             <a:picLocks noChangeAspect="1"/>
           </p:cNvPicPr>
@@ -10234,7 +10496,7 @@
       </p:pic>
       <p:pic>
         <p:nvPicPr>
-          <p:cNvPr id="1579033048" name="Picture 2" descr="image.png"/>
+          <p:cNvPr id="142631627" name="Picture 2" descr="image.png"/>
           <p:cNvPicPr>
             <a:picLocks noChangeAspect="1"/>
           </p:cNvPicPr>
@@ -10256,7 +10518,7 @@
       </p:pic>
       <p:pic>
         <p:nvPicPr>
-          <p:cNvPr id="604670827" name="Picture 3" descr="image.png"/>
+          <p:cNvPr id="647463116" name="Picture 3" descr="image.png"/>
           <p:cNvPicPr>
             <a:picLocks noChangeAspect="1"/>
           </p:cNvPicPr>
@@ -10278,7 +10540,7 @@
       </p:pic>
       <p:pic>
         <p:nvPicPr>
-          <p:cNvPr id="115636864" name="Picture 4" descr="image.png"/>
+          <p:cNvPr id="310240476" name="Picture 4" descr="image.png"/>
           <p:cNvPicPr>
             <a:picLocks noChangeAspect="1"/>
           </p:cNvPicPr>
@@ -10300,7 +10562,7 @@
       </p:pic>
       <p:sp>
         <p:nvSpPr>
-          <p:cNvPr id="987211582" name="TextBox 5"/>
+          <p:cNvPr id="2136104766" name="TextBox 5"/>
           <p:cNvSpPr txBox="1"/>
           <p:nvPr/>
         </p:nvSpPr>
@@ -10338,7 +10600,7 @@
       </p:sp>
       <p:sp>
         <p:nvSpPr>
-          <p:cNvPr id="1504075422" name="TextBox 6"/>
+          <p:cNvPr id="1426122908" name="TextBox 6"/>
           <p:cNvSpPr txBox="1"/>
           <p:nvPr/>
         </p:nvSpPr>
@@ -10379,7 +10641,7 @@
       </p:sp>
       <p:sp>
         <p:nvSpPr>
-          <p:cNvPr id="137708780" name="TextBox 7"/>
+          <p:cNvPr id="443341600" name="TextBox 7"/>
           <p:cNvSpPr txBox="1"/>
           <p:nvPr/>
         </p:nvSpPr>
@@ -10420,7 +10682,7 @@
       </p:sp>
       <p:sp>
         <p:nvSpPr>
-          <p:cNvPr id="1570860396" name="TextBox 8"/>
+          <p:cNvPr id="1690333546" name="TextBox 8"/>
           <p:cNvSpPr txBox="1"/>
           <p:nvPr/>
         </p:nvSpPr>
@@ -10458,7 +10720,7 @@
       </p:sp>
       <p:sp>
         <p:nvSpPr>
-          <p:cNvPr id="1839970910" name="TextBox 9"/>
+          <p:cNvPr id="321104905" name="TextBox 9"/>
           <p:cNvSpPr txBox="1"/>
           <p:nvPr/>
         </p:nvSpPr>
@@ -10499,7 +10761,7 @@
       </p:sp>
       <p:sp>
         <p:nvSpPr>
-          <p:cNvPr id="1669943881" name="TextBox 10"/>
+          <p:cNvPr id="1980455569" name="TextBox 10"/>
           <p:cNvSpPr txBox="1"/>
           <p:nvPr/>
         </p:nvSpPr>
@@ -10540,7 +10802,7 @@
       </p:sp>
       <p:pic>
         <p:nvPicPr>
-          <p:cNvPr id="1137393304" name="Picture 11" descr="image.png"/>
+          <p:cNvPr id="1061675152" name="Picture 11" descr="image.png"/>
           <p:cNvPicPr>
             <a:picLocks noChangeAspect="1"/>
           </p:cNvPicPr>
@@ -10562,7 +10824,7 @@
       </p:pic>
       <p:pic>
         <p:nvPicPr>
-          <p:cNvPr id="491861543" name="Picture 12" descr="image.png"/>
+          <p:cNvPr id="1671992853" name="Picture 12" descr="image.png"/>
           <p:cNvPicPr>
             <a:picLocks noChangeAspect="1"/>
           </p:cNvPicPr>
@@ -10584,7 +10846,7 @@
       </p:pic>
       <p:sp>
         <p:nvSpPr>
-          <p:cNvPr id="1373047747" name="TextBox 13"/>
+          <p:cNvPr id="1764651507" name="TextBox 13"/>
           <p:cNvSpPr txBox="1"/>
           <p:nvPr/>
         </p:nvSpPr>
@@ -10616,6 +10878,32 @@
               </a:rPr>
               <a:t>Data Persistence &amp; File I/O</a:t>
             </a:r>
+            <a:endParaRPr/>
+          </a:p>
+        </p:txBody>
+      </p:sp>
+      <p:sp>
+        <p:nvSpPr>
+          <p:cNvPr id="878917610" name="Slide Number Placeholder 3"/>
+          <p:cNvSpPr>
+            <a:spLocks noGrp="1"/>
+          </p:cNvSpPr>
+          <p:nvPr>
+            <p:ph type="sldNum" sz="quarter" idx="12"/>
+          </p:nvPr>
+        </p:nvSpPr>
+        <p:spPr bwMode="auto"/>
+        <p:txBody>
+          <a:bodyPr/>
+          <a:lstStyle/>
+          <a:p>
+            <a:pPr>
+              <a:defRPr/>
+            </a:pPr>
+            <a:fld id="{1DE1E2BC-0EB5-502F-2FAE-DD449562F840}" type="slidenum">
+              <a:rPr lang="en-US"/>
+              <a:t>1</a:t>
+            </a:fld>
             <a:endParaRPr/>
           </a:p>
         </p:txBody>
@@ -10662,7 +10950,7 @@
       </p:grpSpPr>
       <p:pic>
         <p:nvPicPr>
-          <p:cNvPr id="242958210" name="Picture 1" descr="image.png"/>
+          <p:cNvPr id="1058665090" name="Picture 1" descr="image.png"/>
           <p:cNvPicPr>
             <a:picLocks noChangeAspect="1"/>
           </p:cNvPicPr>
@@ -10684,7 +10972,7 @@
       </p:pic>
       <p:pic>
         <p:nvPicPr>
-          <p:cNvPr id="178932594" name="Picture 2" descr="image.png"/>
+          <p:cNvPr id="996285203" name="Picture 2" descr="image.png"/>
           <p:cNvPicPr>
             <a:picLocks noChangeAspect="1"/>
           </p:cNvPicPr>
@@ -10706,7 +10994,7 @@
       </p:pic>
       <p:graphicFrame>
         <p:nvGraphicFramePr>
-          <p:cNvPr id="667024769" name="Table 3"/>
+          <p:cNvPr id="571307836" name="Table 3"/>
           <p:cNvGraphicFramePr>
             <a:graphicFrameLocks xmlns:a="http://schemas.openxmlformats.org/drawingml/2006/main" noGrp="1"/>
           </p:cNvGraphicFramePr>
@@ -11634,7 +11922,7 @@
       </p:graphicFrame>
       <p:sp>
         <p:nvSpPr>
-          <p:cNvPr id="519961836" name="Rectangle 4"/>
+          <p:cNvPr id="746904428" name="Rectangle 4"/>
           <p:cNvSpPr/>
           <p:nvPr/>
         </p:nvSpPr>
@@ -11681,7 +11969,7 @@
       </p:sp>
       <p:sp>
         <p:nvSpPr>
-          <p:cNvPr id="94643041" name="Rectangle 5"/>
+          <p:cNvPr id="814062833" name="Rectangle 5"/>
           <p:cNvSpPr/>
           <p:nvPr/>
         </p:nvSpPr>
@@ -11728,7 +12016,7 @@
       </p:sp>
       <p:sp>
         <p:nvSpPr>
-          <p:cNvPr id="81721777" name="Rectangle 6"/>
+          <p:cNvPr id="626531281" name="Rectangle 6"/>
           <p:cNvSpPr/>
           <p:nvPr/>
         </p:nvSpPr>
@@ -11775,7 +12063,7 @@
       </p:sp>
       <p:sp>
         <p:nvSpPr>
-          <p:cNvPr id="23080862" name="Rectangle 7"/>
+          <p:cNvPr id="1583802821" name="Rectangle 7"/>
           <p:cNvSpPr/>
           <p:nvPr/>
         </p:nvSpPr>
@@ -11822,7 +12110,7 @@
       </p:sp>
       <p:sp>
         <p:nvSpPr>
-          <p:cNvPr id="1864922732" name="Rectangle 8"/>
+          <p:cNvPr id="312775685" name="Rectangle 8"/>
           <p:cNvSpPr/>
           <p:nvPr/>
         </p:nvSpPr>
@@ -11869,7 +12157,7 @@
       </p:sp>
       <p:sp>
         <p:nvSpPr>
-          <p:cNvPr id="833406689" name="Rectangle 9"/>
+          <p:cNvPr id="726037828" name="Rectangle 9"/>
           <p:cNvSpPr/>
           <p:nvPr/>
         </p:nvSpPr>
@@ -11916,7 +12204,7 @@
       </p:sp>
       <p:sp>
         <p:nvSpPr>
-          <p:cNvPr id="844890463" name="Rectangle 10"/>
+          <p:cNvPr id="984235329" name="Rectangle 10"/>
           <p:cNvSpPr/>
           <p:nvPr/>
         </p:nvSpPr>
@@ -11963,7 +12251,7 @@
       </p:sp>
       <p:sp>
         <p:nvSpPr>
-          <p:cNvPr id="247837684" name="Rectangle 11"/>
+          <p:cNvPr id="1657455768" name="Rectangle 11"/>
           <p:cNvSpPr/>
           <p:nvPr/>
         </p:nvSpPr>
@@ -12010,7 +12298,7 @@
       </p:sp>
       <p:sp>
         <p:nvSpPr>
-          <p:cNvPr id="1944024258" name="Rectangle 12"/>
+          <p:cNvPr id="488218498" name="Rectangle 12"/>
           <p:cNvSpPr/>
           <p:nvPr/>
         </p:nvSpPr>
@@ -12057,7 +12345,7 @@
       </p:sp>
       <p:sp>
         <p:nvSpPr>
-          <p:cNvPr id="535643869" name="Rectangle 13"/>
+          <p:cNvPr id="76582867" name="Rectangle 13"/>
           <p:cNvSpPr/>
           <p:nvPr/>
         </p:nvSpPr>
@@ -12104,7 +12392,7 @@
       </p:sp>
       <p:sp>
         <p:nvSpPr>
-          <p:cNvPr id="1831376919" name="Rectangle 14"/>
+          <p:cNvPr id="501240588" name="Rectangle 14"/>
           <p:cNvSpPr/>
           <p:nvPr/>
         </p:nvSpPr>
@@ -12151,7 +12439,7 @@
       </p:sp>
       <p:sp>
         <p:nvSpPr>
-          <p:cNvPr id="948491426" name="Rectangle 15"/>
+          <p:cNvPr id="1573856287" name="Rectangle 15"/>
           <p:cNvSpPr/>
           <p:nvPr/>
         </p:nvSpPr>
@@ -12198,7 +12486,7 @@
       </p:sp>
       <p:sp>
         <p:nvSpPr>
-          <p:cNvPr id="1445458401" name="Rectangle 16"/>
+          <p:cNvPr id="1396538295" name="Rectangle 16"/>
           <p:cNvSpPr/>
           <p:nvPr/>
         </p:nvSpPr>
@@ -12245,7 +12533,7 @@
       </p:sp>
       <p:sp>
         <p:nvSpPr>
-          <p:cNvPr id="119628899" name="Rectangle 17"/>
+          <p:cNvPr id="304662678" name="Rectangle 17"/>
           <p:cNvSpPr/>
           <p:nvPr/>
         </p:nvSpPr>
@@ -12292,7 +12580,7 @@
       </p:sp>
       <p:sp>
         <p:nvSpPr>
-          <p:cNvPr id="508841391" name="Rectangle 18"/>
+          <p:cNvPr id="1929465441" name="Rectangle 18"/>
           <p:cNvSpPr/>
           <p:nvPr/>
         </p:nvSpPr>
@@ -12339,7 +12627,7 @@
       </p:sp>
       <p:sp>
         <p:nvSpPr>
-          <p:cNvPr id="202019918" name="Rectangle 19"/>
+          <p:cNvPr id="1527198336" name="Rectangle 19"/>
           <p:cNvSpPr/>
           <p:nvPr/>
         </p:nvSpPr>
@@ -12386,7 +12674,7 @@
       </p:sp>
       <p:sp>
         <p:nvSpPr>
-          <p:cNvPr id="1966603933" name="Rectangle 20"/>
+          <p:cNvPr id="486190702" name="Rectangle 20"/>
           <p:cNvSpPr/>
           <p:nvPr/>
         </p:nvSpPr>
@@ -12433,7 +12721,7 @@
       </p:sp>
       <p:sp>
         <p:nvSpPr>
-          <p:cNvPr id="1525732150" name="Rectangle 21"/>
+          <p:cNvPr id="1812313601" name="Rectangle 21"/>
           <p:cNvSpPr/>
           <p:nvPr/>
         </p:nvSpPr>
@@ -12480,7 +12768,7 @@
       </p:sp>
       <p:sp>
         <p:nvSpPr>
-          <p:cNvPr id="1419063564" name="Rectangle 22"/>
+          <p:cNvPr id="1446156908" name="Rectangle 22"/>
           <p:cNvSpPr/>
           <p:nvPr/>
         </p:nvSpPr>
@@ -12527,7 +12815,7 @@
       </p:sp>
       <p:sp>
         <p:nvSpPr>
-          <p:cNvPr id="488100467" name="Rectangle 23"/>
+          <p:cNvPr id="1606871512" name="Rectangle 23"/>
           <p:cNvSpPr/>
           <p:nvPr/>
         </p:nvSpPr>
@@ -12574,7 +12862,7 @@
       </p:sp>
       <p:sp>
         <p:nvSpPr>
-          <p:cNvPr id="2042865151" name="TextBox 24"/>
+          <p:cNvPr id="1355788928" name="TextBox 24"/>
           <p:cNvSpPr txBox="1"/>
           <p:nvPr/>
         </p:nvSpPr>
@@ -12606,6 +12894,32 @@
               </a:rPr>
               <a:t>Testing Matrix &amp; Edge Cases</a:t>
             </a:r>
+            <a:endParaRPr/>
+          </a:p>
+        </p:txBody>
+      </p:sp>
+      <p:sp>
+        <p:nvSpPr>
+          <p:cNvPr id="776130335" name="Slide Number Placeholder 3"/>
+          <p:cNvSpPr>
+            <a:spLocks noGrp="1"/>
+          </p:cNvSpPr>
+          <p:nvPr>
+            <p:ph type="sldNum" sz="quarter" idx="12"/>
+          </p:nvPr>
+        </p:nvSpPr>
+        <p:spPr bwMode="auto"/>
+        <p:txBody>
+          <a:bodyPr/>
+          <a:lstStyle/>
+          <a:p>
+            <a:pPr>
+              <a:defRPr/>
+            </a:pPr>
+            <a:fld id="{EA682B9E-D9F1-466F-EC9E-986D44BA8B43}" type="slidenum">
+              <a:rPr lang="en-US"/>
+              <a:t>1</a:t>
+            </a:fld>
             <a:endParaRPr/>
           </a:p>
         </p:txBody>

</xml_diff>